<commit_message>
Add updated PPT and DEMO_SCRIPT
</commit_message>
<xml_diff>
--- a/presentation/Samsung_PRISM_Theme05.pptx
+++ b/presentation/Samsung_PRISM_Theme05.pptx
@@ -3111,7 +3111,7 @@
           <a:lstStyle/>
           <a:p>
             <a:r>
-              <a:t>Problem / Motivation</a:t>
+              <a:t>1. Problem / Motivation</a:t>
             </a:r>
           </a:p>
         </p:txBody>
@@ -3132,20 +3132,20 @@
           <a:lstStyle/>
           <a:p>
             <a:r>
-              <a:rPr sz="1800"/>
-              <a:t>- LLM agents traditionally block on tool execution.</a:t>
-            </a:r>
-          </a:p>
-          <a:p>
-            <a:r>
-              <a:rPr sz="1800"/>
-              <a:t>- Real-world voice conversations demand real-time interruption.</a:t>
-            </a:r>
-          </a:p>
-          <a:p>
-            <a:r>
-              <a:rPr sz="1800"/>
-              <a:t>- Challenge: Build an interruptible agent resisting stale data mutations.</a:t>
+              <a:rPr sz="1600"/>
+              <a:t>- Need: Interruptible real-time voice agents (e.g. driving assistants).</a:t>
+            </a:r>
+          </a:p>
+          <a:p>
+            <a:r>
+              <a:rPr sz="1600"/>
+              <a:t>- Issue: Normal sequential voice agents fail under interruption or self-correction.</a:t>
+            </a:r>
+          </a:p>
+          <a:p>
+            <a:r>
+              <a:rPr sz="1600"/>
+              <a:t>- Result: Stale state mutations, blocking UI, and poor user experience.</a:t>
             </a:r>
           </a:p>
         </p:txBody>
@@ -3184,7 +3184,7 @@
           <a:lstStyle/>
           <a:p>
             <a:r>
-              <a:t>Theme 05 Requirements</a:t>
+              <a:t>2. Proposed Solution</a:t>
             </a:r>
           </a:p>
         </p:txBody>
@@ -3205,26 +3205,32 @@
           <a:lstStyle/>
           <a:p>
             <a:r>
-              <a:rPr sz="1800"/>
-              <a:t>- Fast Path: Acknowledge immediately.</a:t>
-            </a:r>
-          </a:p>
-          <a:p>
-            <a:r>
-              <a:rPr sz="1800"/>
-              <a:t>- Slow Path: Async background tool execution.</a:t>
-            </a:r>
-          </a:p>
-          <a:p>
-            <a:r>
-              <a:rPr sz="1800"/>
-              <a:t>- Full-Duplex: Graceful interruption handling and rollback prevention.</a:t>
-            </a:r>
-          </a:p>
-          <a:p>
-            <a:r>
-              <a:rPr sz="1800"/>
-              <a:t>- Evaluation: LiveKit Voice Agent via FDB-v3.</a:t>
+              <a:rPr sz="1600"/>
+              <a:t>- Coordination Layer: Orchestrates events between speech, LLM, and tools.</a:t>
+            </a:r>
+          </a:p>
+          <a:p>
+            <a:r>
+              <a:rPr sz="1600"/>
+              <a:t>- Fast/Slow Path: Acknowledge fast, execute tools async in background.</a:t>
+            </a:r>
+          </a:p>
+          <a:p>
+            <a:r>
+              <a:rPr sz="1600"/>
+              <a:t>- Interruption Detection: Cancel tasks when intent changes.</a:t>
+            </a:r>
+          </a:p>
+          <a:p>
+            <a:r>
+              <a:rPr sz="1600"/>
+              <a:t>- State Generations: Rollback protection via stale-result rejection.</a:t>
+            </a:r>
+          </a:p>
+          <a:p>
+            <a:r>
+              <a:rPr sz="1600"/>
+              <a:t>- Tool Validation: Idempotent operations.</a:t>
             </a:r>
           </a:p>
         </p:txBody>
@@ -3263,7 +3269,7 @@
           <a:lstStyle/>
           <a:p>
             <a:r>
-              <a:t>Architecture</a:t>
+              <a:t>3. Architecture</a:t>
             </a:r>
           </a:p>
         </p:txBody>
@@ -3284,20 +3290,20 @@
           <a:lstStyle/>
           <a:p>
             <a:r>
-              <a:rPr sz="1800"/>
-              <a:t>- livekit_agent.py: WebRTC LiveKit Voice Pipeline (STT -&gt; LLM -&gt; TTS).</a:t>
-            </a:r>
-          </a:p>
-          <a:p>
-            <a:r>
-              <a:rPr sz="1800"/>
-              <a:t>- core.py: Concurrency-safe event processing loop.</a:t>
-            </a:r>
-          </a:p>
-          <a:p>
-            <a:r>
-              <a:rPr sz="1800"/>
-              <a:t>- state.py: Generational state snapshotting.</a:t>
+              <a:rPr sz="1600"/>
+              <a:t>- LiveKit Voice Agent Pipeline (STT -&gt; LLM -&gt; TTS).</a:t>
+            </a:r>
+          </a:p>
+          <a:p>
+            <a:r>
+              <a:rPr sz="1600"/>
+              <a:t>- Tool Layer: Custom @function_tool wrappers.</a:t>
+            </a:r>
+          </a:p>
+          <a:p>
+            <a:r>
+              <a:rPr sz="1600"/>
+              <a:t>- Interruption Flow: VAD speech trigger interrupts TTS, increments generation, cancels pending tool executions safely.</a:t>
             </a:r>
           </a:p>
         </p:txBody>
@@ -3336,7 +3342,7 @@
           <a:lstStyle/>
           <a:p>
             <a:r>
-              <a:t>LiveKit + FDB-v3 Integration</a:t>
+              <a:t>4. FDB-v3 Benchmark Integration</a:t>
             </a:r>
           </a:p>
         </p:txBody>
@@ -3357,20 +3363,26 @@
           <a:lstStyle/>
           <a:p>
             <a:r>
-              <a:rPr sz="1800"/>
-              <a:t>- Built on livekit-agents and livekit-plugins-openai.</a:t>
-            </a:r>
-          </a:p>
-          <a:p>
-            <a:r>
-              <a:rPr sz="1800"/>
-              <a:t>- Uses llm.ai_callable plugins delegating to internal coordination engine.</a:t>
-            </a:r>
-          </a:p>
-          <a:p>
-            <a:r>
-              <a:rPr sz="1800"/>
-              <a:t>- FDB-v3 compatibility achieved through standard LiveKit entrypoints.</a:t>
+              <a:rPr sz="1600"/>
+              <a:t>- Official FDB-v3 Evaluation Framework.</a:t>
+            </a:r>
+          </a:p>
+          <a:p>
+            <a:r>
+              <a:rPr sz="1600"/>
+              <a:t>- LiveKit WebRTC backend.</a:t>
+            </a:r>
+          </a:p>
+          <a:p>
+            <a:r>
+              <a:rPr sz="1600"/>
+              <a:t>- Real Human Disfluencies: Handling mid-sentence corrections.</a:t>
+            </a:r>
+          </a:p>
+          <a:p>
+            <a:r>
+              <a:rPr sz="1600"/>
+              <a:t>- Tool Calling: Async dispatch mapped to generation states.</a:t>
             </a:r>
           </a:p>
         </p:txBody>
@@ -3409,7 +3421,7 @@
           <a:lstStyle/>
           <a:p>
             <a:r>
-              <a:t>Interruption / Cancellation</a:t>
+              <a:t>5. Actual Benchmark Results (LOCAL/PARTIAL)</a:t>
             </a:r>
           </a:p>
         </p:txBody>
@@ -3430,20 +3442,32 @@
           <a:lstStyle/>
           <a:p>
             <a:r>
-              <a:rPr sz="1800"/>
-              <a:t>- Interruptions increment the generation counter on SessionState.</a:t>
-            </a:r>
-          </a:p>
-          <a:p>
-            <a:r>
-              <a:rPr sz="1800"/>
-              <a:t>- Active async tasks map to a stale generation.</a:t>
-            </a:r>
-          </a:p>
-          <a:p>
-            <a:r>
-              <a:rPr sz="1800"/>
-              <a:t>- Tasks are either CancelledError aborted or structurally ignored.</a:t>
+              <a:rPr sz="1600"/>
+              <a:t>- 30/100 scenarios completed. Run stopped at #30 due to Groq API 429 rate limit.</a:t>
+            </a:r>
+          </a:p>
+          <a:p>
+            <a:r>
+              <a:rPr sz="1600"/>
+              <a:t>- Tool Selection Accuracy: 77.3%</a:t>
+            </a:r>
+          </a:p>
+          <a:p>
+            <a:r>
+              <a:rPr sz="1600"/>
+              <a:t>- Argument Accuracy: 47.0%</a:t>
+            </a:r>
+          </a:p>
+          <a:p>
+            <a:r>
+              <a:rPr sz="1600"/>
+              <a:t>- Strict Pass Rate: 33.3%</a:t>
+            </a:r>
+          </a:p>
+          <a:p>
+            <a:r>
+              <a:rPr sz="1600"/>
+              <a:t>- Note: These are partial results from fallback models (qwen3.8-27b), not 100-scenario metrics.</a:t>
             </a:r>
           </a:p>
         </p:txBody>
@@ -3482,7 +3506,7 @@
           <a:lstStyle/>
           <a:p>
             <a:r>
-              <a:t>Benchmark Results (FDB-v3)</a:t>
+              <a:t>6. Extension Use Case (In-Car Assistant)</a:t>
             </a:r>
           </a:p>
         </p:txBody>
@@ -3503,32 +3527,20 @@
           <a:lstStyle/>
           <a:p>
             <a:r>
-              <a:rPr sz="1800"/>
-              <a:t>- Status: Benchmark completed partially (30/100) due to Groq rate limits.</a:t>
-            </a:r>
-          </a:p>
-          <a:p>
-            <a:r>
-              <a:rPr sz="1800"/>
-              <a:t>- Tool Selection Acc: 77.3%</a:t>
-            </a:r>
-          </a:p>
-          <a:p>
-            <a:r>
-              <a:rPr sz="1800"/>
-              <a:t>- Argument Acc: 47.0%</a:t>
-            </a:r>
-          </a:p>
-          <a:p>
-            <a:r>
-              <a:rPr sz="1800"/>
-              <a:t>- Strict Pass Rate: 33.3%</a:t>
-            </a:r>
-          </a:p>
-          <a:p>
-            <a:r>
-              <a:rPr sz="1800"/>
-              <a:t>- Evaluation script used: evaluate_tool_calls.py and evaluate_pass_rate.py</a:t>
+              <a:rPr sz="1600"/>
+              <a:t>- Scenario: In-Car Destination Change Assistant.</a:t>
+            </a:r>
+          </a:p>
+          <a:p>
+            <a:r>
+              <a:rPr sz="1600"/>
+              <a:t>- Flow: Navigate to 'Chennai Central' -&gt; Interrupt -&gt; Correct to 'VIT Vellore'.</a:t>
+            </a:r>
+          </a:p>
+          <a:p>
+            <a:r>
+              <a:rPr sz="1600"/>
+              <a:t>- Resolution: Stale route (Chennai) is discarded; corrected destination (VIT Vellore) is processed cleanly.</a:t>
             </a:r>
           </a:p>
         </p:txBody>
@@ -3567,7 +3579,7 @@
           <a:lstStyle/>
           <a:p>
             <a:r>
-              <a:t>Extension Use Case - In-Car</a:t>
+              <a:t>7. Demo &amp; Reproducibility</a:t>
             </a:r>
           </a:p>
         </p:txBody>
@@ -3588,20 +3600,20 @@
           <a:lstStyle/>
           <a:p>
             <a:r>
-              <a:rPr sz="1800"/>
-              <a:t>- Scenario: Driver navigates to 'Chennai Central', then corrects to 'VIT Vellore'.</a:t>
-            </a:r>
-          </a:p>
-          <a:p>
-            <a:r>
-              <a:rPr sz="1800"/>
-              <a:t>- Execution: Initial routing canceled/ignored in real-time.</a:t>
-            </a:r>
-          </a:p>
-          <a:p>
-            <a:r>
-              <a:rPr sz="1800"/>
-              <a:t>- Agent routes to new destination without duplicate state mutation.</a:t>
+              <a:rPr sz="1600"/>
+              <a:t>- Reproducible: Full tool layer, async interception, and single-sample run.</a:t>
+            </a:r>
+          </a:p>
+          <a:p>
+            <a:r>
+              <a:rPr sz="1600"/>
+              <a:t>- Limitations: GPT-4o dependent metrics (Latency/LLM-judge) are unavailable locally and not claimed.</a:t>
+            </a:r>
+          </a:p>
+          <a:p>
+            <a:r>
+              <a:rPr sz="1600"/>
+              <a:t>- Environment: Python 3.11, LiveKit Agents 1.8.3, Groq LLM/STT, ElevenLabs TTS.</a:t>
             </a:r>
           </a:p>
         </p:txBody>
@@ -3640,7 +3652,7 @@
           <a:lstStyle/>
           <a:p>
             <a:r>
-              <a:t>Conclusion / Next Steps</a:t>
+              <a:t>8. Conclusion &amp; Disclosures</a:t>
             </a:r>
           </a:p>
         </p:txBody>
@@ -3661,20 +3673,20 @@
           <a:lstStyle/>
           <a:p>
             <a:r>
-              <a:rPr sz="1800"/>
-              <a:t>- Built a highly robust, full-duplex conversational coordinator.</a:t>
-            </a:r>
-          </a:p>
-          <a:p>
-            <a:r>
-              <a:rPr sz="1800"/>
-              <a:t>- Solves LLM latency bottlenecks elegantly.</a:t>
-            </a:r>
-          </a:p>
-          <a:p>
-            <a:r>
-              <a:rPr sz="1800"/>
-              <a:t>- Next Step: Enterprise-scale cloud deployment.</a:t>
+              <a:rPr sz="1600"/>
+              <a:t>- Built a strictly robust, full-duplex conversational coordinator.</a:t>
+            </a:r>
+          </a:p>
+          <a:p>
+            <a:r>
+              <a:rPr sz="1600"/>
+              <a:t>- AI Disclosure: Developed with assistance from Google DeepMind Antigravity AI for architecture design and testing.</a:t>
+            </a:r>
+          </a:p>
+          <a:p>
+            <a:r>
+              <a:rPr sz="1600"/>
+              <a:t>- GitHub Repo: TiyasDas-81/Samsung_Prism</a:t>
             </a:r>
           </a:p>
         </p:txBody>

</xml_diff>

<commit_message>
Update final PRISM presentation
</commit_message>
<xml_diff>
--- a/presentation/Samsung_PRISM_Theme05.pptx
+++ b/presentation/Samsung_PRISM_Theme05.pptx
@@ -5,16 +5,16 @@
     <p:sldMasterId id="2147483648" r:id="rId1"/>
   </p:sldMasterIdLst>
   <p:sldIdLst>
-    <p:sldId id="256" r:id="rId7"/>
-    <p:sldId id="257" r:id="rId8"/>
-    <p:sldId id="258" r:id="rId9"/>
-    <p:sldId id="259" r:id="rId10"/>
-    <p:sldId id="260" r:id="rId11"/>
-    <p:sldId id="261" r:id="rId12"/>
-    <p:sldId id="262" r:id="rId13"/>
-    <p:sldId id="263" r:id="rId14"/>
+    <p:sldId id="256" r:id="rId2"/>
+    <p:sldId id="257" r:id="rId3"/>
+    <p:sldId id="258" r:id="rId4"/>
+    <p:sldId id="259" r:id="rId5"/>
+    <p:sldId id="260" r:id="rId6"/>
+    <p:sldId id="261" r:id="rId7"/>
+    <p:sldId id="262" r:id="rId8"/>
+    <p:sldId id="263" r:id="rId9"/>
   </p:sldIdLst>
-  <p:sldSz cx="12191695" cy="6858000" type="screen4x3"/>
+  <p:sldSz cx="12192000" cy="6858000"/>
   <p:notesSz cx="6858000" cy="9144000"/>
   <p:defaultTextStyle>
     <a:defPPr>
@@ -111,6 +111,22 @@
       </a:defRPr>
     </a:lvl9pPr>
   </p:defaultTextStyle>
+  <p:extLst>
+    <p:ext uri="{EFAFB233-063F-42B5-8137-9DF3F51BA10A}">
+      <p15:sldGuideLst xmlns:p15="http://schemas.microsoft.com/office/powerpoint/2012/main">
+        <p15:guide id="1" orient="horz" pos="2160">
+          <p15:clr>
+            <a:srgbClr val="A4A3A4"/>
+          </p15:clr>
+        </p15:guide>
+        <p15:guide id="2" pos="2880">
+          <p15:clr>
+            <a:srgbClr val="A4A3A4"/>
+          </p15:clr>
+        </p15:guide>
+      </p15:sldGuideLst>
+    </p:ext>
+  </p:extLst>
 </p:presentation>
 </file>
 
@@ -152,10 +168,9 @@
           <a:lstStyle/>
           <a:p>
             <a:r>
-              <a:rPr lang="en-US" smtClean="0"/>
+              <a:rPr lang="en-US"/>
               <a:t>Click to edit Master title style</a:t>
             </a:r>
-            <a:endParaRPr lang="en-US"/>
           </a:p>
         </p:txBody>
       </p:sp>
@@ -271,10 +286,9 @@
           </a:lstStyle>
           <a:p>
             <a:r>
-              <a:rPr lang="en-US" smtClean="0"/>
+              <a:rPr lang="en-US"/>
               <a:t>Click to edit Master subtitle style</a:t>
             </a:r>
-            <a:endParaRPr lang="en-US"/>
           </a:p>
         </p:txBody>
       </p:sp>
@@ -295,7 +309,7 @@
           <a:p>
             <a:fld id="{5BCAD085-E8A6-8845-BD4E-CB4CCA059FC4}" type="datetimeFigureOut">
               <a:rPr lang="en-US" smtClean="0"/>
-              <a:t>1/27/13</a:t>
+              <a:t>10/4/2026</a:t>
             </a:fld>
             <a:endParaRPr lang="en-US"/>
           </a:p>
@@ -389,10 +403,9 @@
           <a:lstStyle/>
           <a:p>
             <a:r>
-              <a:rPr lang="en-US" smtClean="0"/>
+              <a:rPr lang="en-US"/>
               <a:t>Click to edit Master title style</a:t>
             </a:r>
-            <a:endParaRPr lang="en-US"/>
           </a:p>
         </p:txBody>
       </p:sp>
@@ -413,38 +426,37 @@
           <a:p>
             <a:pPr lvl="0"/>
             <a:r>
-              <a:rPr lang="en-US" smtClean="0"/>
+              <a:rPr lang="en-US"/>
               <a:t>Click to edit Master text styles</a:t>
             </a:r>
           </a:p>
           <a:p>
             <a:pPr lvl="1"/>
             <a:r>
-              <a:rPr lang="en-US" smtClean="0"/>
+              <a:rPr lang="en-US"/>
               <a:t>Second level</a:t>
             </a:r>
           </a:p>
           <a:p>
             <a:pPr lvl="2"/>
             <a:r>
-              <a:rPr lang="en-US" smtClean="0"/>
+              <a:rPr lang="en-US"/>
               <a:t>Third level</a:t>
             </a:r>
           </a:p>
           <a:p>
             <a:pPr lvl="3"/>
             <a:r>
-              <a:rPr lang="en-US" smtClean="0"/>
+              <a:rPr lang="en-US"/>
               <a:t>Fourth level</a:t>
             </a:r>
           </a:p>
           <a:p>
             <a:pPr lvl="4"/>
             <a:r>
-              <a:rPr lang="en-US" smtClean="0"/>
+              <a:rPr lang="en-US"/>
               <a:t>Fifth level</a:t>
             </a:r>
-            <a:endParaRPr lang="en-US"/>
           </a:p>
         </p:txBody>
       </p:sp>
@@ -465,7 +477,7 @@
           <a:p>
             <a:fld id="{5BCAD085-E8A6-8845-BD4E-CB4CCA059FC4}" type="datetimeFigureOut">
               <a:rPr lang="en-US" smtClean="0"/>
-              <a:t>1/27/13</a:t>
+              <a:t>10/4/2026</a:t>
             </a:fld>
             <a:endParaRPr lang="en-US"/>
           </a:p>
@@ -564,10 +576,9 @@
           <a:lstStyle/>
           <a:p>
             <a:r>
-              <a:rPr lang="en-US" smtClean="0"/>
+              <a:rPr lang="en-US"/>
               <a:t>Click to edit Master title style</a:t>
             </a:r>
-            <a:endParaRPr lang="en-US"/>
           </a:p>
         </p:txBody>
       </p:sp>
@@ -593,38 +604,37 @@
           <a:p>
             <a:pPr lvl="0"/>
             <a:r>
-              <a:rPr lang="en-US" smtClean="0"/>
+              <a:rPr lang="en-US"/>
               <a:t>Click to edit Master text styles</a:t>
             </a:r>
           </a:p>
           <a:p>
             <a:pPr lvl="1"/>
             <a:r>
-              <a:rPr lang="en-US" smtClean="0"/>
+              <a:rPr lang="en-US"/>
               <a:t>Second level</a:t>
             </a:r>
           </a:p>
           <a:p>
             <a:pPr lvl="2"/>
             <a:r>
-              <a:rPr lang="en-US" smtClean="0"/>
+              <a:rPr lang="en-US"/>
               <a:t>Third level</a:t>
             </a:r>
           </a:p>
           <a:p>
             <a:pPr lvl="3"/>
             <a:r>
-              <a:rPr lang="en-US" smtClean="0"/>
+              <a:rPr lang="en-US"/>
               <a:t>Fourth level</a:t>
             </a:r>
           </a:p>
           <a:p>
             <a:pPr lvl="4"/>
             <a:r>
-              <a:rPr lang="en-US" smtClean="0"/>
+              <a:rPr lang="en-US"/>
               <a:t>Fifth level</a:t>
             </a:r>
-            <a:endParaRPr lang="en-US"/>
           </a:p>
         </p:txBody>
       </p:sp>
@@ -645,7 +655,7 @@
           <a:p>
             <a:fld id="{5BCAD085-E8A6-8845-BD4E-CB4CCA059FC4}" type="datetimeFigureOut">
               <a:rPr lang="en-US" smtClean="0"/>
-              <a:t>1/27/13</a:t>
+              <a:t>10/4/2026</a:t>
             </a:fld>
             <a:endParaRPr lang="en-US"/>
           </a:p>
@@ -739,10 +749,9 @@
           <a:lstStyle/>
           <a:p>
             <a:r>
-              <a:rPr lang="en-US" smtClean="0"/>
+              <a:rPr lang="en-US"/>
               <a:t>Click to edit Master title style</a:t>
             </a:r>
-            <a:endParaRPr lang="en-US"/>
           </a:p>
         </p:txBody>
       </p:sp>
@@ -763,38 +772,37 @@
           <a:p>
             <a:pPr lvl="0"/>
             <a:r>
-              <a:rPr lang="en-US" smtClean="0"/>
+              <a:rPr lang="en-US"/>
               <a:t>Click to edit Master text styles</a:t>
             </a:r>
           </a:p>
           <a:p>
             <a:pPr lvl="1"/>
             <a:r>
-              <a:rPr lang="en-US" smtClean="0"/>
+              <a:rPr lang="en-US"/>
               <a:t>Second level</a:t>
             </a:r>
           </a:p>
           <a:p>
             <a:pPr lvl="2"/>
             <a:r>
-              <a:rPr lang="en-US" smtClean="0"/>
+              <a:rPr lang="en-US"/>
               <a:t>Third level</a:t>
             </a:r>
           </a:p>
           <a:p>
             <a:pPr lvl="3"/>
             <a:r>
-              <a:rPr lang="en-US" smtClean="0"/>
+              <a:rPr lang="en-US"/>
               <a:t>Fourth level</a:t>
             </a:r>
           </a:p>
           <a:p>
             <a:pPr lvl="4"/>
             <a:r>
-              <a:rPr lang="en-US" smtClean="0"/>
+              <a:rPr lang="en-US"/>
               <a:t>Fifth level</a:t>
             </a:r>
-            <a:endParaRPr lang="en-US"/>
           </a:p>
         </p:txBody>
       </p:sp>
@@ -815,7 +823,7 @@
           <a:p>
             <a:fld id="{5BCAD085-E8A6-8845-BD4E-CB4CCA059FC4}" type="datetimeFigureOut">
               <a:rPr lang="en-US" smtClean="0"/>
-              <a:t>1/27/13</a:t>
+              <a:t>10/4/2026</a:t>
             </a:fld>
             <a:endParaRPr lang="en-US"/>
           </a:p>
@@ -918,10 +926,9 @@
           </a:lstStyle>
           <a:p>
             <a:r>
-              <a:rPr lang="en-US" smtClean="0"/>
+              <a:rPr lang="en-US"/>
               <a:t>Click to edit Master title style</a:t>
             </a:r>
-            <a:endParaRPr lang="en-US"/>
           </a:p>
         </p:txBody>
       </p:sp>
@@ -1038,7 +1045,7 @@
           <a:p>
             <a:pPr lvl="0"/>
             <a:r>
-              <a:rPr lang="en-US" smtClean="0"/>
+              <a:rPr lang="en-US"/>
               <a:t>Click to edit Master text styles</a:t>
             </a:r>
           </a:p>
@@ -1061,7 +1068,7 @@
           <a:p>
             <a:fld id="{5BCAD085-E8A6-8845-BD4E-CB4CCA059FC4}" type="datetimeFigureOut">
               <a:rPr lang="en-US" smtClean="0"/>
-              <a:t>1/27/13</a:t>
+              <a:t>10/4/2026</a:t>
             </a:fld>
             <a:endParaRPr lang="en-US"/>
           </a:p>
@@ -1155,10 +1162,9 @@
           <a:lstStyle/>
           <a:p>
             <a:r>
-              <a:rPr lang="en-US" smtClean="0"/>
+              <a:rPr lang="en-US"/>
               <a:t>Click to edit Master title style</a:t>
             </a:r>
-            <a:endParaRPr lang="en-US"/>
           </a:p>
         </p:txBody>
       </p:sp>
@@ -1212,38 +1218,37 @@
           <a:p>
             <a:pPr lvl="0"/>
             <a:r>
-              <a:rPr lang="en-US" smtClean="0"/>
+              <a:rPr lang="en-US"/>
               <a:t>Click to edit Master text styles</a:t>
             </a:r>
           </a:p>
           <a:p>
             <a:pPr lvl="1"/>
             <a:r>
-              <a:rPr lang="en-US" smtClean="0"/>
+              <a:rPr lang="en-US"/>
               <a:t>Second level</a:t>
             </a:r>
           </a:p>
           <a:p>
             <a:pPr lvl="2"/>
             <a:r>
-              <a:rPr lang="en-US" smtClean="0"/>
+              <a:rPr lang="en-US"/>
               <a:t>Third level</a:t>
             </a:r>
           </a:p>
           <a:p>
             <a:pPr lvl="3"/>
             <a:r>
-              <a:rPr lang="en-US" smtClean="0"/>
+              <a:rPr lang="en-US"/>
               <a:t>Fourth level</a:t>
             </a:r>
           </a:p>
           <a:p>
             <a:pPr lvl="4"/>
             <a:r>
-              <a:rPr lang="en-US" smtClean="0"/>
+              <a:rPr lang="en-US"/>
               <a:t>Fifth level</a:t>
             </a:r>
-            <a:endParaRPr lang="en-US"/>
           </a:p>
         </p:txBody>
       </p:sp>
@@ -1297,38 +1302,37 @@
           <a:p>
             <a:pPr lvl="0"/>
             <a:r>
-              <a:rPr lang="en-US" smtClean="0"/>
+              <a:rPr lang="en-US"/>
               <a:t>Click to edit Master text styles</a:t>
             </a:r>
           </a:p>
           <a:p>
             <a:pPr lvl="1"/>
             <a:r>
-              <a:rPr lang="en-US" smtClean="0"/>
+              <a:rPr lang="en-US"/>
               <a:t>Second level</a:t>
             </a:r>
           </a:p>
           <a:p>
             <a:pPr lvl="2"/>
             <a:r>
-              <a:rPr lang="en-US" smtClean="0"/>
+              <a:rPr lang="en-US"/>
               <a:t>Third level</a:t>
             </a:r>
           </a:p>
           <a:p>
             <a:pPr lvl="3"/>
             <a:r>
-              <a:rPr lang="en-US" smtClean="0"/>
+              <a:rPr lang="en-US"/>
               <a:t>Fourth level</a:t>
             </a:r>
           </a:p>
           <a:p>
             <a:pPr lvl="4"/>
             <a:r>
-              <a:rPr lang="en-US" smtClean="0"/>
+              <a:rPr lang="en-US"/>
               <a:t>Fifth level</a:t>
             </a:r>
-            <a:endParaRPr lang="en-US"/>
           </a:p>
         </p:txBody>
       </p:sp>
@@ -1349,7 +1353,7 @@
           <a:p>
             <a:fld id="{5BCAD085-E8A6-8845-BD4E-CB4CCA059FC4}" type="datetimeFigureOut">
               <a:rPr lang="en-US" smtClean="0"/>
-              <a:t>1/27/13</a:t>
+              <a:t>10/4/2026</a:t>
             </a:fld>
             <a:endParaRPr lang="en-US"/>
           </a:p>
@@ -1447,10 +1451,9 @@
           </a:lstStyle>
           <a:p>
             <a:r>
-              <a:rPr lang="en-US" smtClean="0"/>
+              <a:rPr lang="en-US"/>
               <a:t>Click to edit Master title style</a:t>
             </a:r>
-            <a:endParaRPr lang="en-US"/>
           </a:p>
         </p:txBody>
       </p:sp>
@@ -1513,7 +1516,7 @@
           <a:p>
             <a:pPr lvl="0"/>
             <a:r>
-              <a:rPr lang="en-US" smtClean="0"/>
+              <a:rPr lang="en-US"/>
               <a:t>Click to edit Master text styles</a:t>
             </a:r>
           </a:p>
@@ -1569,38 +1572,37 @@
           <a:p>
             <a:pPr lvl="0"/>
             <a:r>
-              <a:rPr lang="en-US" smtClean="0"/>
+              <a:rPr lang="en-US"/>
               <a:t>Click to edit Master text styles</a:t>
             </a:r>
           </a:p>
           <a:p>
             <a:pPr lvl="1"/>
             <a:r>
-              <a:rPr lang="en-US" smtClean="0"/>
+              <a:rPr lang="en-US"/>
               <a:t>Second level</a:t>
             </a:r>
           </a:p>
           <a:p>
             <a:pPr lvl="2"/>
             <a:r>
-              <a:rPr lang="en-US" smtClean="0"/>
+              <a:rPr lang="en-US"/>
               <a:t>Third level</a:t>
             </a:r>
           </a:p>
           <a:p>
             <a:pPr lvl="3"/>
             <a:r>
-              <a:rPr lang="en-US" smtClean="0"/>
+              <a:rPr lang="en-US"/>
               <a:t>Fourth level</a:t>
             </a:r>
           </a:p>
           <a:p>
             <a:pPr lvl="4"/>
             <a:r>
-              <a:rPr lang="en-US" smtClean="0"/>
+              <a:rPr lang="en-US"/>
               <a:t>Fifth level</a:t>
             </a:r>
-            <a:endParaRPr lang="en-US"/>
           </a:p>
         </p:txBody>
       </p:sp>
@@ -1663,7 +1665,7 @@
           <a:p>
             <a:pPr lvl="0"/>
             <a:r>
-              <a:rPr lang="en-US" smtClean="0"/>
+              <a:rPr lang="en-US"/>
               <a:t>Click to edit Master text styles</a:t>
             </a:r>
           </a:p>
@@ -1719,38 +1721,37 @@
           <a:p>
             <a:pPr lvl="0"/>
             <a:r>
-              <a:rPr lang="en-US" smtClean="0"/>
+              <a:rPr lang="en-US"/>
               <a:t>Click to edit Master text styles</a:t>
             </a:r>
           </a:p>
           <a:p>
             <a:pPr lvl="1"/>
             <a:r>
-              <a:rPr lang="en-US" smtClean="0"/>
+              <a:rPr lang="en-US"/>
               <a:t>Second level</a:t>
             </a:r>
           </a:p>
           <a:p>
             <a:pPr lvl="2"/>
             <a:r>
-              <a:rPr lang="en-US" smtClean="0"/>
+              <a:rPr lang="en-US"/>
               <a:t>Third level</a:t>
             </a:r>
           </a:p>
           <a:p>
             <a:pPr lvl="3"/>
             <a:r>
-              <a:rPr lang="en-US" smtClean="0"/>
+              <a:rPr lang="en-US"/>
               <a:t>Fourth level</a:t>
             </a:r>
           </a:p>
           <a:p>
             <a:pPr lvl="4"/>
             <a:r>
-              <a:rPr lang="en-US" smtClean="0"/>
+              <a:rPr lang="en-US"/>
               <a:t>Fifth level</a:t>
             </a:r>
-            <a:endParaRPr lang="en-US"/>
           </a:p>
         </p:txBody>
       </p:sp>
@@ -1771,7 +1772,7 @@
           <a:p>
             <a:fld id="{5BCAD085-E8A6-8845-BD4E-CB4CCA059FC4}" type="datetimeFigureOut">
               <a:rPr lang="en-US" smtClean="0"/>
-              <a:t>1/27/13</a:t>
+              <a:t>10/4/2026</a:t>
             </a:fld>
             <a:endParaRPr lang="en-US"/>
           </a:p>
@@ -1865,10 +1866,9 @@
           <a:lstStyle/>
           <a:p>
             <a:r>
-              <a:rPr lang="en-US" smtClean="0"/>
+              <a:rPr lang="en-US"/>
               <a:t>Click to edit Master title style</a:t>
             </a:r>
-            <a:endParaRPr lang="en-US"/>
           </a:p>
         </p:txBody>
       </p:sp>
@@ -1889,7 +1889,7 @@
           <a:p>
             <a:fld id="{5BCAD085-E8A6-8845-BD4E-CB4CCA059FC4}" type="datetimeFigureOut">
               <a:rPr lang="en-US" smtClean="0"/>
-              <a:t>1/27/13</a:t>
+              <a:t>10/4/2026</a:t>
             </a:fld>
             <a:endParaRPr lang="en-US"/>
           </a:p>
@@ -1984,7 +1984,7 @@
           <a:p>
             <a:fld id="{5BCAD085-E8A6-8845-BD4E-CB4CCA059FC4}" type="datetimeFigureOut">
               <a:rPr lang="en-US" smtClean="0"/>
-              <a:t>1/27/13</a:t>
+              <a:t>10/4/2026</a:t>
             </a:fld>
             <a:endParaRPr lang="en-US"/>
           </a:p>
@@ -2087,10 +2087,9 @@
           </a:lstStyle>
           <a:p>
             <a:r>
-              <a:rPr lang="en-US" smtClean="0"/>
+              <a:rPr lang="en-US"/>
               <a:t>Click to edit Master title style</a:t>
             </a:r>
-            <a:endParaRPr lang="en-US"/>
           </a:p>
         </p:txBody>
       </p:sp>
@@ -2144,38 +2143,37 @@
           <a:p>
             <a:pPr lvl="0"/>
             <a:r>
-              <a:rPr lang="en-US" smtClean="0"/>
+              <a:rPr lang="en-US"/>
               <a:t>Click to edit Master text styles</a:t>
             </a:r>
           </a:p>
           <a:p>
             <a:pPr lvl="1"/>
             <a:r>
-              <a:rPr lang="en-US" smtClean="0"/>
+              <a:rPr lang="en-US"/>
               <a:t>Second level</a:t>
             </a:r>
           </a:p>
           <a:p>
             <a:pPr lvl="2"/>
             <a:r>
-              <a:rPr lang="en-US" smtClean="0"/>
+              <a:rPr lang="en-US"/>
               <a:t>Third level</a:t>
             </a:r>
           </a:p>
           <a:p>
             <a:pPr lvl="3"/>
             <a:r>
-              <a:rPr lang="en-US" smtClean="0"/>
+              <a:rPr lang="en-US"/>
               <a:t>Fourth level</a:t>
             </a:r>
           </a:p>
           <a:p>
             <a:pPr lvl="4"/>
             <a:r>
-              <a:rPr lang="en-US" smtClean="0"/>
+              <a:rPr lang="en-US"/>
               <a:t>Fifth level</a:t>
             </a:r>
-            <a:endParaRPr lang="en-US"/>
           </a:p>
         </p:txBody>
       </p:sp>
@@ -2238,7 +2236,7 @@
           <a:p>
             <a:pPr lvl="0"/>
             <a:r>
-              <a:rPr lang="en-US" smtClean="0"/>
+              <a:rPr lang="en-US"/>
               <a:t>Click to edit Master text styles</a:t>
             </a:r>
           </a:p>
@@ -2261,7 +2259,7 @@
           <a:p>
             <a:fld id="{5BCAD085-E8A6-8845-BD4E-CB4CCA059FC4}" type="datetimeFigureOut">
               <a:rPr lang="en-US" smtClean="0"/>
-              <a:t>1/27/13</a:t>
+              <a:t>10/4/2026</a:t>
             </a:fld>
             <a:endParaRPr lang="en-US"/>
           </a:p>
@@ -2364,10 +2362,9 @@
           </a:lstStyle>
           <a:p>
             <a:r>
-              <a:rPr lang="en-US" smtClean="0"/>
+              <a:rPr lang="en-US"/>
               <a:t>Click to edit Master title style</a:t>
             </a:r>
-            <a:endParaRPr lang="en-US"/>
           </a:p>
         </p:txBody>
       </p:sp>
@@ -2491,7 +2488,7 @@
           <a:p>
             <a:pPr lvl="0"/>
             <a:r>
-              <a:rPr lang="en-US" smtClean="0"/>
+              <a:rPr lang="en-US"/>
               <a:t>Click to edit Master text styles</a:t>
             </a:r>
           </a:p>
@@ -2514,7 +2511,7 @@
           <a:p>
             <a:fld id="{5BCAD085-E8A6-8845-BD4E-CB4CCA059FC4}" type="datetimeFigureOut">
               <a:rPr lang="en-US" smtClean="0"/>
-              <a:t>1/27/13</a:t>
+              <a:t>10/4/2026</a:t>
             </a:fld>
             <a:endParaRPr lang="en-US"/>
           </a:p>
@@ -2623,10 +2620,9 @@
           <a:lstStyle/>
           <a:p>
             <a:r>
-              <a:rPr lang="en-US" smtClean="0"/>
+              <a:rPr lang="en-US"/>
               <a:t>Click to edit Master title style</a:t>
             </a:r>
-            <a:endParaRPr lang="en-US"/>
           </a:p>
         </p:txBody>
       </p:sp>
@@ -2657,38 +2653,37 @@
           <a:p>
             <a:pPr lvl="0"/>
             <a:r>
-              <a:rPr lang="en-US" smtClean="0"/>
+              <a:rPr lang="en-US"/>
               <a:t>Click to edit Master text styles</a:t>
             </a:r>
           </a:p>
           <a:p>
             <a:pPr lvl="1"/>
             <a:r>
-              <a:rPr lang="en-US" smtClean="0"/>
+              <a:rPr lang="en-US"/>
               <a:t>Second level</a:t>
             </a:r>
           </a:p>
           <a:p>
             <a:pPr lvl="2"/>
             <a:r>
-              <a:rPr lang="en-US" smtClean="0"/>
+              <a:rPr lang="en-US"/>
               <a:t>Third level</a:t>
             </a:r>
           </a:p>
           <a:p>
             <a:pPr lvl="3"/>
             <a:r>
-              <a:rPr lang="en-US" smtClean="0"/>
+              <a:rPr lang="en-US"/>
               <a:t>Fourth level</a:t>
             </a:r>
           </a:p>
           <a:p>
             <a:pPr lvl="4"/>
             <a:r>
-              <a:rPr lang="en-US" smtClean="0"/>
+              <a:rPr lang="en-US"/>
               <a:t>Fifth level</a:t>
             </a:r>
-            <a:endParaRPr lang="en-US"/>
           </a:p>
         </p:txBody>
       </p:sp>
@@ -2727,7 +2722,7 @@
           <a:p>
             <a:fld id="{5BCAD085-E8A6-8845-BD4E-CB4CCA059FC4}" type="datetimeFigureOut">
               <a:rPr lang="en-US" smtClean="0"/>
-              <a:t>1/27/13</a:t>
+              <a:t>10/4/2026</a:t>
             </a:fld>
             <a:endParaRPr lang="en-US"/>
           </a:p>
@@ -3086,7 +3081,7 @@
 </file>
 
 <file path=ppt/slides/slide1.xml><?xml version="1.0" encoding="utf-8"?>
-<p:sld xmlns:a="http://schemas.openxmlformats.org/drawingml/2006/main" xmlns:p="http://schemas.openxmlformats.org/presentationml/2006/main" xmlns:r="http://schemas.openxmlformats.org/officeDocument/2006/relationships">
+<p:sld xmlns:a="http://schemas.openxmlformats.org/drawingml/2006/main" xmlns:r="http://schemas.openxmlformats.org/officeDocument/2006/relationships" xmlns:p="http://schemas.openxmlformats.org/presentationml/2006/main">
   <p:cSld>
     <p:bg>
       <p:bgPr>
@@ -3102,7 +3097,14 @@
         <p:cNvGrpSpPr/>
         <p:nvPr/>
       </p:nvGrpSpPr>
-      <p:grpSpPr/>
+      <p:grpSpPr>
+        <a:xfrm>
+          <a:off x="0" y="0"/>
+          <a:ext cx="0" cy="0"/>
+          <a:chOff x="0" y="0"/>
+          <a:chExt cx="0" cy="0"/>
+        </a:xfrm>
+      </p:grpSpPr>
       <p:sp>
         <p:nvSpPr>
           <p:cNvPr id="2" name="TextBox 1"/>
@@ -3215,6 +3217,7 @@
           <a:lstStyle/>
           <a:p>
             <a:pPr algn="ctr"/>
+            <a:endParaRPr/>
           </a:p>
         </p:txBody>
       </p:sp>
@@ -3260,6 +3263,7 @@
           <a:lstStyle/>
           <a:p>
             <a:pPr algn="ctr"/>
+            <a:endParaRPr/>
           </a:p>
         </p:txBody>
       </p:sp>
@@ -3415,7 +3419,7 @@
 </file>
 
 <file path=ppt/slides/slide2.xml><?xml version="1.0" encoding="utf-8"?>
-<p:sld xmlns:a="http://schemas.openxmlformats.org/drawingml/2006/main" xmlns:p="http://schemas.openxmlformats.org/presentationml/2006/main" xmlns:r="http://schemas.openxmlformats.org/officeDocument/2006/relationships">
+<p:sld xmlns:a="http://schemas.openxmlformats.org/drawingml/2006/main" xmlns:r="http://schemas.openxmlformats.org/officeDocument/2006/relationships" xmlns:p="http://schemas.openxmlformats.org/presentationml/2006/main">
   <p:cSld>
     <p:bg>
       <p:bgPr>
@@ -3431,7 +3435,14 @@
         <p:cNvGrpSpPr/>
         <p:nvPr/>
       </p:nvGrpSpPr>
-      <p:grpSpPr/>
+      <p:grpSpPr>
+        <a:xfrm>
+          <a:off x="0" y="0"/>
+          <a:ext cx="0" cy="0"/>
+          <a:chOff x="0" y="0"/>
+          <a:chExt cx="0" cy="0"/>
+        </a:xfrm>
+      </p:grpSpPr>
       <p:sp>
         <p:nvSpPr>
           <p:cNvPr id="2" name="TextBox 1"/>
@@ -3789,6 +3800,7 @@
           <a:lstStyle/>
           <a:p>
             <a:pPr algn="ctr"/>
+            <a:endParaRPr/>
           </a:p>
         </p:txBody>
       </p:sp>
@@ -3875,7 +3887,7 @@
 </file>
 
 <file path=ppt/slides/slide3.xml><?xml version="1.0" encoding="utf-8"?>
-<p:sld xmlns:a="http://schemas.openxmlformats.org/drawingml/2006/main" xmlns:p="http://schemas.openxmlformats.org/presentationml/2006/main" xmlns:r="http://schemas.openxmlformats.org/officeDocument/2006/relationships">
+<p:sld xmlns:a="http://schemas.openxmlformats.org/drawingml/2006/main" xmlns:r="http://schemas.openxmlformats.org/officeDocument/2006/relationships" xmlns:p="http://schemas.openxmlformats.org/presentationml/2006/main">
   <p:cSld>
     <p:bg>
       <p:bgPr>
@@ -3891,7 +3903,14 @@
         <p:cNvGrpSpPr/>
         <p:nvPr/>
       </p:nvGrpSpPr>
-      <p:grpSpPr/>
+      <p:grpSpPr>
+        <a:xfrm>
+          <a:off x="0" y="0"/>
+          <a:ext cx="0" cy="0"/>
+          <a:chOff x="0" y="0"/>
+          <a:chExt cx="0" cy="0"/>
+        </a:xfrm>
+      </p:grpSpPr>
       <p:sp>
         <p:nvSpPr>
           <p:cNvPr id="2" name="TextBox 1"/>
@@ -3969,6 +3988,7 @@
           <a:lstStyle/>
           <a:p>
             <a:pPr algn="ctr"/>
+            <a:endParaRPr/>
           </a:p>
         </p:txBody>
       </p:sp>
@@ -4084,6 +4104,7 @@
           <a:lstStyle/>
           <a:p>
             <a:pPr algn="ctr"/>
+            <a:endParaRPr/>
           </a:p>
         </p:txBody>
       </p:sp>
@@ -4199,6 +4220,7 @@
           <a:lstStyle/>
           <a:p>
             <a:pPr algn="ctr"/>
+            <a:endParaRPr/>
           </a:p>
         </p:txBody>
       </p:sp>
@@ -4314,6 +4336,7 @@
           <a:lstStyle/>
           <a:p>
             <a:pPr algn="ctr"/>
+            <a:endParaRPr/>
           </a:p>
         </p:txBody>
       </p:sp>
@@ -4429,6 +4452,7 @@
           <a:lstStyle/>
           <a:p>
             <a:pPr algn="ctr"/>
+            <a:endParaRPr/>
           </a:p>
         </p:txBody>
       </p:sp>
@@ -4544,6 +4568,7 @@
           <a:lstStyle/>
           <a:p>
             <a:pPr algn="ctr"/>
+            <a:endParaRPr/>
           </a:p>
         </p:txBody>
       </p:sp>
@@ -4626,7 +4651,7 @@
 </file>
 
 <file path=ppt/slides/slide4.xml><?xml version="1.0" encoding="utf-8"?>
-<p:sld xmlns:a="http://schemas.openxmlformats.org/drawingml/2006/main" xmlns:p="http://schemas.openxmlformats.org/presentationml/2006/main" xmlns:r="http://schemas.openxmlformats.org/officeDocument/2006/relationships">
+<p:sld xmlns:a="http://schemas.openxmlformats.org/drawingml/2006/main" xmlns:r="http://schemas.openxmlformats.org/officeDocument/2006/relationships" xmlns:p="http://schemas.openxmlformats.org/presentationml/2006/main">
   <p:cSld>
     <p:bg>
       <p:bgPr>
@@ -4642,7 +4667,14 @@
         <p:cNvGrpSpPr/>
         <p:nvPr/>
       </p:nvGrpSpPr>
-      <p:grpSpPr/>
+      <p:grpSpPr>
+        <a:xfrm>
+          <a:off x="0" y="0"/>
+          <a:ext cx="0" cy="0"/>
+          <a:chOff x="0" y="0"/>
+          <a:chExt cx="0" cy="0"/>
+        </a:xfrm>
+      </p:grpSpPr>
       <p:sp>
         <p:nvSpPr>
           <p:cNvPr id="2" name="TextBox 1"/>
@@ -4720,6 +4752,7 @@
           <a:lstStyle/>
           <a:p>
             <a:pPr algn="ctr"/>
+            <a:endParaRPr/>
           </a:p>
         </p:txBody>
       </p:sp>
@@ -4835,6 +4868,7 @@
           <a:lstStyle/>
           <a:p>
             <a:pPr algn="ctr"/>
+            <a:endParaRPr/>
           </a:p>
         </p:txBody>
       </p:sp>
@@ -4950,6 +4984,7 @@
           <a:lstStyle/>
           <a:p>
             <a:pPr algn="ctr"/>
+            <a:endParaRPr/>
           </a:p>
         </p:txBody>
       </p:sp>
@@ -5031,8 +5066,8 @@
         </p:nvSpPr>
         <p:spPr>
           <a:xfrm>
-            <a:off x="4032504" y="2606040"/>
-            <a:ext cx="4114800" cy="1600200"/>
+            <a:off x="4032504" y="2628901"/>
+            <a:ext cx="4114800" cy="1463039"/>
           </a:xfrm>
           <a:prstGeom prst="roundRect">
             <a:avLst/>
@@ -5065,6 +5100,7 @@
           <a:lstStyle/>
           <a:p>
             <a:pPr algn="ctr"/>
+            <a:endParaRPr/>
           </a:p>
         </p:txBody>
       </p:sp>
@@ -5076,8 +5112,8 @@
         </p:nvSpPr>
         <p:spPr>
           <a:xfrm>
-            <a:off x="4123944" y="2651760"/>
-            <a:ext cx="3931920" cy="1371600"/>
+            <a:off x="4032504" y="2583179"/>
+            <a:ext cx="4037131" cy="1492716"/>
           </a:xfrm>
           <a:prstGeom prst="rect">
             <a:avLst/>
@@ -5091,15 +5127,60 @@
           <a:lstStyle/>
           <a:p>
             <a:pPr algn="ctr"/>
-            <a:r>
-              <a:rPr sz="1300" b="1">
+            <a:endParaRPr lang="en-US" sz="1300" b="1" dirty="0">
+              <a:solidFill>
+                <a:srgbClr val="F0F0F0"/>
+              </a:solidFill>
+              <a:latin typeface="Arial"/>
+            </a:endParaRPr>
+          </a:p>
+          <a:p>
+            <a:pPr algn="ctr"/>
+            <a:r>
+              <a:rPr sz="1300" b="1" dirty="0">
                 <a:solidFill>
                   <a:srgbClr val="F0F0F0"/>
                 </a:solidFill>
                 <a:latin typeface="Arial"/>
               </a:rPr>
               <a:t>INTERRUPTION-AWARE COORDINATION LAYER
-generation_id
+</a:t>
+            </a:r>
+            <a:endParaRPr lang="en-US" sz="1300" b="1" dirty="0">
+              <a:solidFill>
+                <a:srgbClr val="F0F0F0"/>
+              </a:solidFill>
+              <a:latin typeface="Arial"/>
+            </a:endParaRPr>
+          </a:p>
+          <a:p>
+            <a:pPr algn="ctr"/>
+            <a:endParaRPr lang="en-IN" sz="1300" b="1" dirty="0">
+              <a:solidFill>
+                <a:srgbClr val="F0F0F0"/>
+              </a:solidFill>
+              <a:latin typeface="Arial"/>
+            </a:endParaRPr>
+          </a:p>
+          <a:p>
+            <a:pPr algn="ctr"/>
+            <a:r>
+              <a:rPr sz="1300" b="1" dirty="0" err="1">
+                <a:solidFill>
+                  <a:srgbClr val="F0F0F0"/>
+                </a:solidFill>
+                <a:latin typeface="Arial"/>
+              </a:rPr>
+              <a:t>generation_id</a:t>
+            </a:r>
+            <a:r>
+              <a:rPr sz="1300" b="1" dirty="0">
+                <a:solidFill>
+                  <a:srgbClr val="F0F0F0"/>
+                </a:solidFill>
+                <a:latin typeface="Arial"/>
+              </a:rPr>
+              <a:t>
 cancellation
 state validation</a:t>
             </a:r>
@@ -5183,6 +5264,7 @@
           <a:lstStyle/>
           <a:p>
             <a:pPr algn="ctr"/>
+            <a:endParaRPr/>
           </a:p>
         </p:txBody>
       </p:sp>
@@ -5298,6 +5380,7 @@
           <a:lstStyle/>
           <a:p>
             <a:pPr algn="ctr"/>
+            <a:endParaRPr/>
           </a:p>
         </p:txBody>
       </p:sp>
@@ -5413,6 +5496,7 @@
           <a:lstStyle/>
           <a:p>
             <a:pPr algn="ctr"/>
+            <a:endParaRPr/>
           </a:p>
         </p:txBody>
       </p:sp>
@@ -5528,6 +5612,7 @@
           <a:lstStyle/>
           <a:p>
             <a:pPr algn="ctr"/>
+            <a:endParaRPr/>
           </a:p>
         </p:txBody>
       </p:sp>
@@ -5575,7 +5660,7 @@
         <p:spPr>
           <a:xfrm>
             <a:off x="1371600" y="2697480"/>
-            <a:ext cx="2377440" cy="1097280"/>
+            <a:ext cx="2377440" cy="1203960"/>
           </a:xfrm>
           <a:prstGeom prst="roundRect">
             <a:avLst/>
@@ -5608,6 +5693,7 @@
           <a:lstStyle/>
           <a:p>
             <a:pPr algn="ctr"/>
+            <a:endParaRPr/>
           </a:p>
         </p:txBody>
       </p:sp>
@@ -5619,7 +5705,7 @@
         </p:nvSpPr>
         <p:spPr>
           <a:xfrm>
-            <a:off x="1463040" y="2788920"/>
+            <a:off x="1490472" y="2702560"/>
             <a:ext cx="2194560" cy="914400"/>
           </a:xfrm>
           <a:prstGeom prst="rect">
@@ -5635,7 +5721,7 @@
           <a:p>
             <a:pPr algn="ctr"/>
             <a:r>
-              <a:rPr sz="1300" b="1">
+              <a:rPr sz="1300" b="1" dirty="0">
                 <a:solidFill>
                   <a:srgbClr val="FF6600"/>
                 </a:solidFill>
@@ -5692,6 +5778,7 @@
           <a:lstStyle/>
           <a:p>
             <a:pPr algn="ctr"/>
+            <a:endParaRPr/>
           </a:p>
         </p:txBody>
       </p:sp>
@@ -5741,7 +5828,7 @@
 </file>
 
 <file path=ppt/slides/slide5.xml><?xml version="1.0" encoding="utf-8"?>
-<p:sld xmlns:a="http://schemas.openxmlformats.org/drawingml/2006/main" xmlns:p="http://schemas.openxmlformats.org/presentationml/2006/main" xmlns:r="http://schemas.openxmlformats.org/officeDocument/2006/relationships">
+<p:sld xmlns:a="http://schemas.openxmlformats.org/drawingml/2006/main" xmlns:r="http://schemas.openxmlformats.org/officeDocument/2006/relationships" xmlns:p="http://schemas.openxmlformats.org/presentationml/2006/main">
   <p:cSld>
     <p:bg>
       <p:bgPr>
@@ -5757,7 +5844,14 @@
         <p:cNvGrpSpPr/>
         <p:nvPr/>
       </p:nvGrpSpPr>
-      <p:grpSpPr/>
+      <p:grpSpPr>
+        <a:xfrm>
+          <a:off x="0" y="0"/>
+          <a:ext cx="0" cy="0"/>
+          <a:chOff x="0" y="0"/>
+          <a:chExt cx="0" cy="0"/>
+        </a:xfrm>
+      </p:grpSpPr>
       <p:sp>
         <p:nvSpPr>
           <p:cNvPr id="2" name="TextBox 1"/>
@@ -5870,6 +5964,7 @@
           <a:lstStyle/>
           <a:p>
             <a:pPr algn="ctr"/>
+            <a:endParaRPr/>
           </a:p>
         </p:txBody>
       </p:sp>
@@ -5985,6 +6080,7 @@
           <a:lstStyle/>
           <a:p>
             <a:pPr algn="ctr"/>
+            <a:endParaRPr/>
           </a:p>
         </p:txBody>
       </p:sp>
@@ -6100,6 +6196,7 @@
           <a:lstStyle/>
           <a:p>
             <a:pPr algn="ctr"/>
+            <a:endParaRPr/>
           </a:p>
         </p:txBody>
       </p:sp>
@@ -6215,6 +6312,7 @@
           <a:lstStyle/>
           <a:p>
             <a:pPr algn="ctr"/>
+            <a:endParaRPr/>
           </a:p>
         </p:txBody>
       </p:sp>
@@ -6298,7 +6396,7 @@
 </file>
 
 <file path=ppt/slides/slide6.xml><?xml version="1.0" encoding="utf-8"?>
-<p:sld xmlns:a="http://schemas.openxmlformats.org/drawingml/2006/main" xmlns:p="http://schemas.openxmlformats.org/presentationml/2006/main" xmlns:r="http://schemas.openxmlformats.org/officeDocument/2006/relationships">
+<p:sld xmlns:a="http://schemas.openxmlformats.org/drawingml/2006/main" xmlns:r="http://schemas.openxmlformats.org/officeDocument/2006/relationships" xmlns:p="http://schemas.openxmlformats.org/presentationml/2006/main">
   <p:cSld>
     <p:bg>
       <p:bgPr>
@@ -6314,7 +6412,14 @@
         <p:cNvGrpSpPr/>
         <p:nvPr/>
       </p:nvGrpSpPr>
-      <p:grpSpPr/>
+      <p:grpSpPr>
+        <a:xfrm>
+          <a:off x="0" y="0"/>
+          <a:ext cx="0" cy="0"/>
+          <a:chOff x="0" y="0"/>
+          <a:chExt cx="0" cy="0"/>
+        </a:xfrm>
+      </p:grpSpPr>
       <p:sp>
         <p:nvSpPr>
           <p:cNvPr id="2" name="TextBox 1"/>
@@ -6643,6 +6748,7 @@
           <a:lstStyle/>
           <a:p>
             <a:pPr algn="ctr"/>
+            <a:endParaRPr/>
           </a:p>
         </p:txBody>
       </p:sp>
@@ -6724,6 +6830,7 @@
           <a:lstStyle/>
           <a:p>
             <a:pPr algn="ctr"/>
+            <a:endParaRPr/>
           </a:p>
         </p:txBody>
       </p:sp>
@@ -6808,7 +6915,7 @@
 </file>
 
 <file path=ppt/slides/slide7.xml><?xml version="1.0" encoding="utf-8"?>
-<p:sld xmlns:a="http://schemas.openxmlformats.org/drawingml/2006/main" xmlns:p="http://schemas.openxmlformats.org/presentationml/2006/main" xmlns:r="http://schemas.openxmlformats.org/officeDocument/2006/relationships">
+<p:sld xmlns:a="http://schemas.openxmlformats.org/drawingml/2006/main" xmlns:r="http://schemas.openxmlformats.org/officeDocument/2006/relationships" xmlns:p="http://schemas.openxmlformats.org/presentationml/2006/main">
   <p:cSld>
     <p:bg>
       <p:bgPr>
@@ -6824,7 +6931,14 @@
         <p:cNvGrpSpPr/>
         <p:nvPr/>
       </p:nvGrpSpPr>
-      <p:grpSpPr/>
+      <p:grpSpPr>
+        <a:xfrm>
+          <a:off x="0" y="0"/>
+          <a:ext cx="0" cy="0"/>
+          <a:chOff x="0" y="0"/>
+          <a:chExt cx="0" cy="0"/>
+        </a:xfrm>
+      </p:grpSpPr>
       <p:sp>
         <p:nvSpPr>
           <p:cNvPr id="2" name="TextBox 1"/>
@@ -6902,6 +7016,7 @@
           <a:lstStyle/>
           <a:p>
             <a:pPr algn="ctr"/>
+            <a:endParaRPr/>
           </a:p>
         </p:txBody>
       </p:sp>
@@ -7087,6 +7202,7 @@
           <a:lstStyle/>
           <a:p>
             <a:pPr algn="ctr"/>
+            <a:endParaRPr/>
           </a:p>
         </p:txBody>
       </p:sp>
@@ -7272,6 +7388,7 @@
           <a:lstStyle/>
           <a:p>
             <a:pPr algn="ctr"/>
+            <a:endParaRPr/>
           </a:p>
         </p:txBody>
       </p:sp>
@@ -7492,6 +7609,7 @@
           <a:lstStyle/>
           <a:p>
             <a:pPr algn="ctr"/>
+            <a:endParaRPr/>
           </a:p>
         </p:txBody>
       </p:sp>
@@ -7539,7 +7657,7 @@
 </file>
 
 <file path=ppt/slides/slide8.xml><?xml version="1.0" encoding="utf-8"?>
-<p:sld xmlns:a="http://schemas.openxmlformats.org/drawingml/2006/main" xmlns:p="http://schemas.openxmlformats.org/presentationml/2006/main" xmlns:r="http://schemas.openxmlformats.org/officeDocument/2006/relationships">
+<p:sld xmlns:a="http://schemas.openxmlformats.org/drawingml/2006/main" xmlns:r="http://schemas.openxmlformats.org/officeDocument/2006/relationships" xmlns:p="http://schemas.openxmlformats.org/presentationml/2006/main">
   <p:cSld>
     <p:bg>
       <p:bgPr>
@@ -7555,7 +7673,14 @@
         <p:cNvGrpSpPr/>
         <p:nvPr/>
       </p:nvGrpSpPr>
-      <p:grpSpPr/>
+      <p:grpSpPr>
+        <a:xfrm>
+          <a:off x="0" y="0"/>
+          <a:ext cx="0" cy="0"/>
+          <a:chOff x="0" y="0"/>
+          <a:chExt cx="0" cy="0"/>
+        </a:xfrm>
+      </p:grpSpPr>
       <p:sp>
         <p:nvSpPr>
           <p:cNvPr id="2" name="TextBox 1"/>

</xml_diff>

<commit_message>
Finalize Samsung PRISM Theme 05 submission
</commit_message>
<xml_diff>
--- a/presentation/Samsung_PRISM_Theme05.pptx
+++ b/presentation/Samsung_PRISM_Theme05.pptx
@@ -5,16 +5,16 @@
     <p:sldMasterId id="2147483648" r:id="rId1"/>
   </p:sldMasterIdLst>
   <p:sldIdLst>
-    <p:sldId id="256" r:id="rId2"/>
-    <p:sldId id="257" r:id="rId3"/>
-    <p:sldId id="258" r:id="rId4"/>
-    <p:sldId id="259" r:id="rId5"/>
-    <p:sldId id="260" r:id="rId6"/>
-    <p:sldId id="261" r:id="rId7"/>
-    <p:sldId id="262" r:id="rId8"/>
-    <p:sldId id="263" r:id="rId9"/>
+    <p:sldId id="256" r:id="rId7"/>
+    <p:sldId id="257" r:id="rId8"/>
+    <p:sldId id="258" r:id="rId9"/>
+    <p:sldId id="259" r:id="rId10"/>
+    <p:sldId id="260" r:id="rId11"/>
+    <p:sldId id="261" r:id="rId12"/>
+    <p:sldId id="262" r:id="rId13"/>
+    <p:sldId id="263" r:id="rId14"/>
   </p:sldIdLst>
-  <p:sldSz cx="12192000" cy="6858000"/>
+  <p:sldSz cx="12191695" cy="6858000" type="screen4x3"/>
   <p:notesSz cx="6858000" cy="9144000"/>
   <p:defaultTextStyle>
     <a:defPPr>
@@ -111,22 +111,6 @@
       </a:defRPr>
     </a:lvl9pPr>
   </p:defaultTextStyle>
-  <p:extLst>
-    <p:ext uri="{EFAFB233-063F-42B5-8137-9DF3F51BA10A}">
-      <p15:sldGuideLst xmlns:p15="http://schemas.microsoft.com/office/powerpoint/2012/main">
-        <p15:guide id="1" orient="horz" pos="2160">
-          <p15:clr>
-            <a:srgbClr val="A4A3A4"/>
-          </p15:clr>
-        </p15:guide>
-        <p15:guide id="2" pos="2880">
-          <p15:clr>
-            <a:srgbClr val="A4A3A4"/>
-          </p15:clr>
-        </p15:guide>
-      </p15:sldGuideLst>
-    </p:ext>
-  </p:extLst>
 </p:presentation>
 </file>
 
@@ -168,9 +152,10 @@
           <a:lstStyle/>
           <a:p>
             <a:r>
-              <a:rPr lang="en-US"/>
+              <a:rPr lang="en-US" smtClean="0"/>
               <a:t>Click to edit Master title style</a:t>
             </a:r>
+            <a:endParaRPr lang="en-US"/>
           </a:p>
         </p:txBody>
       </p:sp>
@@ -286,9 +271,10 @@
           </a:lstStyle>
           <a:p>
             <a:r>
-              <a:rPr lang="en-US"/>
+              <a:rPr lang="en-US" smtClean="0"/>
               <a:t>Click to edit Master subtitle style</a:t>
             </a:r>
+            <a:endParaRPr lang="en-US"/>
           </a:p>
         </p:txBody>
       </p:sp>
@@ -309,7 +295,7 @@
           <a:p>
             <a:fld id="{5BCAD085-E8A6-8845-BD4E-CB4CCA059FC4}" type="datetimeFigureOut">
               <a:rPr lang="en-US" smtClean="0"/>
-              <a:t>10/4/2026</a:t>
+              <a:t>1/27/13</a:t>
             </a:fld>
             <a:endParaRPr lang="en-US"/>
           </a:p>
@@ -403,9 +389,10 @@
           <a:lstStyle/>
           <a:p>
             <a:r>
-              <a:rPr lang="en-US"/>
+              <a:rPr lang="en-US" smtClean="0"/>
               <a:t>Click to edit Master title style</a:t>
             </a:r>
+            <a:endParaRPr lang="en-US"/>
           </a:p>
         </p:txBody>
       </p:sp>
@@ -426,37 +413,38 @@
           <a:p>
             <a:pPr lvl="0"/>
             <a:r>
-              <a:rPr lang="en-US"/>
+              <a:rPr lang="en-US" smtClean="0"/>
               <a:t>Click to edit Master text styles</a:t>
             </a:r>
           </a:p>
           <a:p>
             <a:pPr lvl="1"/>
             <a:r>
-              <a:rPr lang="en-US"/>
+              <a:rPr lang="en-US" smtClean="0"/>
               <a:t>Second level</a:t>
             </a:r>
           </a:p>
           <a:p>
             <a:pPr lvl="2"/>
             <a:r>
-              <a:rPr lang="en-US"/>
+              <a:rPr lang="en-US" smtClean="0"/>
               <a:t>Third level</a:t>
             </a:r>
           </a:p>
           <a:p>
             <a:pPr lvl="3"/>
             <a:r>
-              <a:rPr lang="en-US"/>
+              <a:rPr lang="en-US" smtClean="0"/>
               <a:t>Fourth level</a:t>
             </a:r>
           </a:p>
           <a:p>
             <a:pPr lvl="4"/>
             <a:r>
-              <a:rPr lang="en-US"/>
+              <a:rPr lang="en-US" smtClean="0"/>
               <a:t>Fifth level</a:t>
             </a:r>
+            <a:endParaRPr lang="en-US"/>
           </a:p>
         </p:txBody>
       </p:sp>
@@ -477,7 +465,7 @@
           <a:p>
             <a:fld id="{5BCAD085-E8A6-8845-BD4E-CB4CCA059FC4}" type="datetimeFigureOut">
               <a:rPr lang="en-US" smtClean="0"/>
-              <a:t>10/4/2026</a:t>
+              <a:t>1/27/13</a:t>
             </a:fld>
             <a:endParaRPr lang="en-US"/>
           </a:p>
@@ -576,9 +564,10 @@
           <a:lstStyle/>
           <a:p>
             <a:r>
-              <a:rPr lang="en-US"/>
+              <a:rPr lang="en-US" smtClean="0"/>
               <a:t>Click to edit Master title style</a:t>
             </a:r>
+            <a:endParaRPr lang="en-US"/>
           </a:p>
         </p:txBody>
       </p:sp>
@@ -604,37 +593,38 @@
           <a:p>
             <a:pPr lvl="0"/>
             <a:r>
-              <a:rPr lang="en-US"/>
+              <a:rPr lang="en-US" smtClean="0"/>
               <a:t>Click to edit Master text styles</a:t>
             </a:r>
           </a:p>
           <a:p>
             <a:pPr lvl="1"/>
             <a:r>
-              <a:rPr lang="en-US"/>
+              <a:rPr lang="en-US" smtClean="0"/>
               <a:t>Second level</a:t>
             </a:r>
           </a:p>
           <a:p>
             <a:pPr lvl="2"/>
             <a:r>
-              <a:rPr lang="en-US"/>
+              <a:rPr lang="en-US" smtClean="0"/>
               <a:t>Third level</a:t>
             </a:r>
           </a:p>
           <a:p>
             <a:pPr lvl="3"/>
             <a:r>
-              <a:rPr lang="en-US"/>
+              <a:rPr lang="en-US" smtClean="0"/>
               <a:t>Fourth level</a:t>
             </a:r>
           </a:p>
           <a:p>
             <a:pPr lvl="4"/>
             <a:r>
-              <a:rPr lang="en-US"/>
+              <a:rPr lang="en-US" smtClean="0"/>
               <a:t>Fifth level</a:t>
             </a:r>
+            <a:endParaRPr lang="en-US"/>
           </a:p>
         </p:txBody>
       </p:sp>
@@ -655,7 +645,7 @@
           <a:p>
             <a:fld id="{5BCAD085-E8A6-8845-BD4E-CB4CCA059FC4}" type="datetimeFigureOut">
               <a:rPr lang="en-US" smtClean="0"/>
-              <a:t>10/4/2026</a:t>
+              <a:t>1/27/13</a:t>
             </a:fld>
             <a:endParaRPr lang="en-US"/>
           </a:p>
@@ -749,9 +739,10 @@
           <a:lstStyle/>
           <a:p>
             <a:r>
-              <a:rPr lang="en-US"/>
+              <a:rPr lang="en-US" smtClean="0"/>
               <a:t>Click to edit Master title style</a:t>
             </a:r>
+            <a:endParaRPr lang="en-US"/>
           </a:p>
         </p:txBody>
       </p:sp>
@@ -772,37 +763,38 @@
           <a:p>
             <a:pPr lvl="0"/>
             <a:r>
-              <a:rPr lang="en-US"/>
+              <a:rPr lang="en-US" smtClean="0"/>
               <a:t>Click to edit Master text styles</a:t>
             </a:r>
           </a:p>
           <a:p>
             <a:pPr lvl="1"/>
             <a:r>
-              <a:rPr lang="en-US"/>
+              <a:rPr lang="en-US" smtClean="0"/>
               <a:t>Second level</a:t>
             </a:r>
           </a:p>
           <a:p>
             <a:pPr lvl="2"/>
             <a:r>
-              <a:rPr lang="en-US"/>
+              <a:rPr lang="en-US" smtClean="0"/>
               <a:t>Third level</a:t>
             </a:r>
           </a:p>
           <a:p>
             <a:pPr lvl="3"/>
             <a:r>
-              <a:rPr lang="en-US"/>
+              <a:rPr lang="en-US" smtClean="0"/>
               <a:t>Fourth level</a:t>
             </a:r>
           </a:p>
           <a:p>
             <a:pPr lvl="4"/>
             <a:r>
-              <a:rPr lang="en-US"/>
+              <a:rPr lang="en-US" smtClean="0"/>
               <a:t>Fifth level</a:t>
             </a:r>
+            <a:endParaRPr lang="en-US"/>
           </a:p>
         </p:txBody>
       </p:sp>
@@ -823,7 +815,7 @@
           <a:p>
             <a:fld id="{5BCAD085-E8A6-8845-BD4E-CB4CCA059FC4}" type="datetimeFigureOut">
               <a:rPr lang="en-US" smtClean="0"/>
-              <a:t>10/4/2026</a:t>
+              <a:t>1/27/13</a:t>
             </a:fld>
             <a:endParaRPr lang="en-US"/>
           </a:p>
@@ -926,9 +918,10 @@
           </a:lstStyle>
           <a:p>
             <a:r>
-              <a:rPr lang="en-US"/>
+              <a:rPr lang="en-US" smtClean="0"/>
               <a:t>Click to edit Master title style</a:t>
             </a:r>
+            <a:endParaRPr lang="en-US"/>
           </a:p>
         </p:txBody>
       </p:sp>
@@ -1045,7 +1038,7 @@
           <a:p>
             <a:pPr lvl="0"/>
             <a:r>
-              <a:rPr lang="en-US"/>
+              <a:rPr lang="en-US" smtClean="0"/>
               <a:t>Click to edit Master text styles</a:t>
             </a:r>
           </a:p>
@@ -1068,7 +1061,7 @@
           <a:p>
             <a:fld id="{5BCAD085-E8A6-8845-BD4E-CB4CCA059FC4}" type="datetimeFigureOut">
               <a:rPr lang="en-US" smtClean="0"/>
-              <a:t>10/4/2026</a:t>
+              <a:t>1/27/13</a:t>
             </a:fld>
             <a:endParaRPr lang="en-US"/>
           </a:p>
@@ -1162,9 +1155,10 @@
           <a:lstStyle/>
           <a:p>
             <a:r>
-              <a:rPr lang="en-US"/>
+              <a:rPr lang="en-US" smtClean="0"/>
               <a:t>Click to edit Master title style</a:t>
             </a:r>
+            <a:endParaRPr lang="en-US"/>
           </a:p>
         </p:txBody>
       </p:sp>
@@ -1218,37 +1212,38 @@
           <a:p>
             <a:pPr lvl="0"/>
             <a:r>
-              <a:rPr lang="en-US"/>
+              <a:rPr lang="en-US" smtClean="0"/>
               <a:t>Click to edit Master text styles</a:t>
             </a:r>
           </a:p>
           <a:p>
             <a:pPr lvl="1"/>
             <a:r>
-              <a:rPr lang="en-US"/>
+              <a:rPr lang="en-US" smtClean="0"/>
               <a:t>Second level</a:t>
             </a:r>
           </a:p>
           <a:p>
             <a:pPr lvl="2"/>
             <a:r>
-              <a:rPr lang="en-US"/>
+              <a:rPr lang="en-US" smtClean="0"/>
               <a:t>Third level</a:t>
             </a:r>
           </a:p>
           <a:p>
             <a:pPr lvl="3"/>
             <a:r>
-              <a:rPr lang="en-US"/>
+              <a:rPr lang="en-US" smtClean="0"/>
               <a:t>Fourth level</a:t>
             </a:r>
           </a:p>
           <a:p>
             <a:pPr lvl="4"/>
             <a:r>
-              <a:rPr lang="en-US"/>
+              <a:rPr lang="en-US" smtClean="0"/>
               <a:t>Fifth level</a:t>
             </a:r>
+            <a:endParaRPr lang="en-US"/>
           </a:p>
         </p:txBody>
       </p:sp>
@@ -1302,37 +1297,38 @@
           <a:p>
             <a:pPr lvl="0"/>
             <a:r>
-              <a:rPr lang="en-US"/>
+              <a:rPr lang="en-US" smtClean="0"/>
               <a:t>Click to edit Master text styles</a:t>
             </a:r>
           </a:p>
           <a:p>
             <a:pPr lvl="1"/>
             <a:r>
-              <a:rPr lang="en-US"/>
+              <a:rPr lang="en-US" smtClean="0"/>
               <a:t>Second level</a:t>
             </a:r>
           </a:p>
           <a:p>
             <a:pPr lvl="2"/>
             <a:r>
-              <a:rPr lang="en-US"/>
+              <a:rPr lang="en-US" smtClean="0"/>
               <a:t>Third level</a:t>
             </a:r>
           </a:p>
           <a:p>
             <a:pPr lvl="3"/>
             <a:r>
-              <a:rPr lang="en-US"/>
+              <a:rPr lang="en-US" smtClean="0"/>
               <a:t>Fourth level</a:t>
             </a:r>
           </a:p>
           <a:p>
             <a:pPr lvl="4"/>
             <a:r>
-              <a:rPr lang="en-US"/>
+              <a:rPr lang="en-US" smtClean="0"/>
               <a:t>Fifth level</a:t>
             </a:r>
+            <a:endParaRPr lang="en-US"/>
           </a:p>
         </p:txBody>
       </p:sp>
@@ -1353,7 +1349,7 @@
           <a:p>
             <a:fld id="{5BCAD085-E8A6-8845-BD4E-CB4CCA059FC4}" type="datetimeFigureOut">
               <a:rPr lang="en-US" smtClean="0"/>
-              <a:t>10/4/2026</a:t>
+              <a:t>1/27/13</a:t>
             </a:fld>
             <a:endParaRPr lang="en-US"/>
           </a:p>
@@ -1451,9 +1447,10 @@
           </a:lstStyle>
           <a:p>
             <a:r>
-              <a:rPr lang="en-US"/>
+              <a:rPr lang="en-US" smtClean="0"/>
               <a:t>Click to edit Master title style</a:t>
             </a:r>
+            <a:endParaRPr lang="en-US"/>
           </a:p>
         </p:txBody>
       </p:sp>
@@ -1516,7 +1513,7 @@
           <a:p>
             <a:pPr lvl="0"/>
             <a:r>
-              <a:rPr lang="en-US"/>
+              <a:rPr lang="en-US" smtClean="0"/>
               <a:t>Click to edit Master text styles</a:t>
             </a:r>
           </a:p>
@@ -1572,37 +1569,38 @@
           <a:p>
             <a:pPr lvl="0"/>
             <a:r>
-              <a:rPr lang="en-US"/>
+              <a:rPr lang="en-US" smtClean="0"/>
               <a:t>Click to edit Master text styles</a:t>
             </a:r>
           </a:p>
           <a:p>
             <a:pPr lvl="1"/>
             <a:r>
-              <a:rPr lang="en-US"/>
+              <a:rPr lang="en-US" smtClean="0"/>
               <a:t>Second level</a:t>
             </a:r>
           </a:p>
           <a:p>
             <a:pPr lvl="2"/>
             <a:r>
-              <a:rPr lang="en-US"/>
+              <a:rPr lang="en-US" smtClean="0"/>
               <a:t>Third level</a:t>
             </a:r>
           </a:p>
           <a:p>
             <a:pPr lvl="3"/>
             <a:r>
-              <a:rPr lang="en-US"/>
+              <a:rPr lang="en-US" smtClean="0"/>
               <a:t>Fourth level</a:t>
             </a:r>
           </a:p>
           <a:p>
             <a:pPr lvl="4"/>
             <a:r>
-              <a:rPr lang="en-US"/>
+              <a:rPr lang="en-US" smtClean="0"/>
               <a:t>Fifth level</a:t>
             </a:r>
+            <a:endParaRPr lang="en-US"/>
           </a:p>
         </p:txBody>
       </p:sp>
@@ -1665,7 +1663,7 @@
           <a:p>
             <a:pPr lvl="0"/>
             <a:r>
-              <a:rPr lang="en-US"/>
+              <a:rPr lang="en-US" smtClean="0"/>
               <a:t>Click to edit Master text styles</a:t>
             </a:r>
           </a:p>
@@ -1721,37 +1719,38 @@
           <a:p>
             <a:pPr lvl="0"/>
             <a:r>
-              <a:rPr lang="en-US"/>
+              <a:rPr lang="en-US" smtClean="0"/>
               <a:t>Click to edit Master text styles</a:t>
             </a:r>
           </a:p>
           <a:p>
             <a:pPr lvl="1"/>
             <a:r>
-              <a:rPr lang="en-US"/>
+              <a:rPr lang="en-US" smtClean="0"/>
               <a:t>Second level</a:t>
             </a:r>
           </a:p>
           <a:p>
             <a:pPr lvl="2"/>
             <a:r>
-              <a:rPr lang="en-US"/>
+              <a:rPr lang="en-US" smtClean="0"/>
               <a:t>Third level</a:t>
             </a:r>
           </a:p>
           <a:p>
             <a:pPr lvl="3"/>
             <a:r>
-              <a:rPr lang="en-US"/>
+              <a:rPr lang="en-US" smtClean="0"/>
               <a:t>Fourth level</a:t>
             </a:r>
           </a:p>
           <a:p>
             <a:pPr lvl="4"/>
             <a:r>
-              <a:rPr lang="en-US"/>
+              <a:rPr lang="en-US" smtClean="0"/>
               <a:t>Fifth level</a:t>
             </a:r>
+            <a:endParaRPr lang="en-US"/>
           </a:p>
         </p:txBody>
       </p:sp>
@@ -1772,7 +1771,7 @@
           <a:p>
             <a:fld id="{5BCAD085-E8A6-8845-BD4E-CB4CCA059FC4}" type="datetimeFigureOut">
               <a:rPr lang="en-US" smtClean="0"/>
-              <a:t>10/4/2026</a:t>
+              <a:t>1/27/13</a:t>
             </a:fld>
             <a:endParaRPr lang="en-US"/>
           </a:p>
@@ -1866,9 +1865,10 @@
           <a:lstStyle/>
           <a:p>
             <a:r>
-              <a:rPr lang="en-US"/>
+              <a:rPr lang="en-US" smtClean="0"/>
               <a:t>Click to edit Master title style</a:t>
             </a:r>
+            <a:endParaRPr lang="en-US"/>
           </a:p>
         </p:txBody>
       </p:sp>
@@ -1889,7 +1889,7 @@
           <a:p>
             <a:fld id="{5BCAD085-E8A6-8845-BD4E-CB4CCA059FC4}" type="datetimeFigureOut">
               <a:rPr lang="en-US" smtClean="0"/>
-              <a:t>10/4/2026</a:t>
+              <a:t>1/27/13</a:t>
             </a:fld>
             <a:endParaRPr lang="en-US"/>
           </a:p>
@@ -1984,7 +1984,7 @@
           <a:p>
             <a:fld id="{5BCAD085-E8A6-8845-BD4E-CB4CCA059FC4}" type="datetimeFigureOut">
               <a:rPr lang="en-US" smtClean="0"/>
-              <a:t>10/4/2026</a:t>
+              <a:t>1/27/13</a:t>
             </a:fld>
             <a:endParaRPr lang="en-US"/>
           </a:p>
@@ -2087,9 +2087,10 @@
           </a:lstStyle>
           <a:p>
             <a:r>
-              <a:rPr lang="en-US"/>
+              <a:rPr lang="en-US" smtClean="0"/>
               <a:t>Click to edit Master title style</a:t>
             </a:r>
+            <a:endParaRPr lang="en-US"/>
           </a:p>
         </p:txBody>
       </p:sp>
@@ -2143,37 +2144,38 @@
           <a:p>
             <a:pPr lvl="0"/>
             <a:r>
-              <a:rPr lang="en-US"/>
+              <a:rPr lang="en-US" smtClean="0"/>
               <a:t>Click to edit Master text styles</a:t>
             </a:r>
           </a:p>
           <a:p>
             <a:pPr lvl="1"/>
             <a:r>
-              <a:rPr lang="en-US"/>
+              <a:rPr lang="en-US" smtClean="0"/>
               <a:t>Second level</a:t>
             </a:r>
           </a:p>
           <a:p>
             <a:pPr lvl="2"/>
             <a:r>
-              <a:rPr lang="en-US"/>
+              <a:rPr lang="en-US" smtClean="0"/>
               <a:t>Third level</a:t>
             </a:r>
           </a:p>
           <a:p>
             <a:pPr lvl="3"/>
             <a:r>
-              <a:rPr lang="en-US"/>
+              <a:rPr lang="en-US" smtClean="0"/>
               <a:t>Fourth level</a:t>
             </a:r>
           </a:p>
           <a:p>
             <a:pPr lvl="4"/>
             <a:r>
-              <a:rPr lang="en-US"/>
+              <a:rPr lang="en-US" smtClean="0"/>
               <a:t>Fifth level</a:t>
             </a:r>
+            <a:endParaRPr lang="en-US"/>
           </a:p>
         </p:txBody>
       </p:sp>
@@ -2236,7 +2238,7 @@
           <a:p>
             <a:pPr lvl="0"/>
             <a:r>
-              <a:rPr lang="en-US"/>
+              <a:rPr lang="en-US" smtClean="0"/>
               <a:t>Click to edit Master text styles</a:t>
             </a:r>
           </a:p>
@@ -2259,7 +2261,7 @@
           <a:p>
             <a:fld id="{5BCAD085-E8A6-8845-BD4E-CB4CCA059FC4}" type="datetimeFigureOut">
               <a:rPr lang="en-US" smtClean="0"/>
-              <a:t>10/4/2026</a:t>
+              <a:t>1/27/13</a:t>
             </a:fld>
             <a:endParaRPr lang="en-US"/>
           </a:p>
@@ -2362,9 +2364,10 @@
           </a:lstStyle>
           <a:p>
             <a:r>
-              <a:rPr lang="en-US"/>
+              <a:rPr lang="en-US" smtClean="0"/>
               <a:t>Click to edit Master title style</a:t>
             </a:r>
+            <a:endParaRPr lang="en-US"/>
           </a:p>
         </p:txBody>
       </p:sp>
@@ -2488,7 +2491,7 @@
           <a:p>
             <a:pPr lvl="0"/>
             <a:r>
-              <a:rPr lang="en-US"/>
+              <a:rPr lang="en-US" smtClean="0"/>
               <a:t>Click to edit Master text styles</a:t>
             </a:r>
           </a:p>
@@ -2511,7 +2514,7 @@
           <a:p>
             <a:fld id="{5BCAD085-E8A6-8845-BD4E-CB4CCA059FC4}" type="datetimeFigureOut">
               <a:rPr lang="en-US" smtClean="0"/>
-              <a:t>10/4/2026</a:t>
+              <a:t>1/27/13</a:t>
             </a:fld>
             <a:endParaRPr lang="en-US"/>
           </a:p>
@@ -2620,9 +2623,10 @@
           <a:lstStyle/>
           <a:p>
             <a:r>
-              <a:rPr lang="en-US"/>
+              <a:rPr lang="en-US" smtClean="0"/>
               <a:t>Click to edit Master title style</a:t>
             </a:r>
+            <a:endParaRPr lang="en-US"/>
           </a:p>
         </p:txBody>
       </p:sp>
@@ -2653,37 +2657,38 @@
           <a:p>
             <a:pPr lvl="0"/>
             <a:r>
-              <a:rPr lang="en-US"/>
+              <a:rPr lang="en-US" smtClean="0"/>
               <a:t>Click to edit Master text styles</a:t>
             </a:r>
           </a:p>
           <a:p>
             <a:pPr lvl="1"/>
             <a:r>
-              <a:rPr lang="en-US"/>
+              <a:rPr lang="en-US" smtClean="0"/>
               <a:t>Second level</a:t>
             </a:r>
           </a:p>
           <a:p>
             <a:pPr lvl="2"/>
             <a:r>
-              <a:rPr lang="en-US"/>
+              <a:rPr lang="en-US" smtClean="0"/>
               <a:t>Third level</a:t>
             </a:r>
           </a:p>
           <a:p>
             <a:pPr lvl="3"/>
             <a:r>
-              <a:rPr lang="en-US"/>
+              <a:rPr lang="en-US" smtClean="0"/>
               <a:t>Fourth level</a:t>
             </a:r>
           </a:p>
           <a:p>
             <a:pPr lvl="4"/>
             <a:r>
-              <a:rPr lang="en-US"/>
+              <a:rPr lang="en-US" smtClean="0"/>
               <a:t>Fifth level</a:t>
             </a:r>
+            <a:endParaRPr lang="en-US"/>
           </a:p>
         </p:txBody>
       </p:sp>
@@ -2722,7 +2727,7 @@
           <a:p>
             <a:fld id="{5BCAD085-E8A6-8845-BD4E-CB4CCA059FC4}" type="datetimeFigureOut">
               <a:rPr lang="en-US" smtClean="0"/>
-              <a:t>10/4/2026</a:t>
+              <a:t>1/27/13</a:t>
             </a:fld>
             <a:endParaRPr lang="en-US"/>
           </a:p>
@@ -3081,7 +3086,7 @@
 </file>
 
 <file path=ppt/slides/slide1.xml><?xml version="1.0" encoding="utf-8"?>
-<p:sld xmlns:a="http://schemas.openxmlformats.org/drawingml/2006/main" xmlns:r="http://schemas.openxmlformats.org/officeDocument/2006/relationships" xmlns:p="http://schemas.openxmlformats.org/presentationml/2006/main">
+<p:sld xmlns:a="http://schemas.openxmlformats.org/drawingml/2006/main" xmlns:p="http://schemas.openxmlformats.org/presentationml/2006/main" xmlns:r="http://schemas.openxmlformats.org/officeDocument/2006/relationships">
   <p:cSld>
     <p:bg>
       <p:bgPr>
@@ -3097,14 +3102,7 @@
         <p:cNvGrpSpPr/>
         <p:nvPr/>
       </p:nvGrpSpPr>
-      <p:grpSpPr>
-        <a:xfrm>
-          <a:off x="0" y="0"/>
-          <a:ext cx="0" cy="0"/>
-          <a:chOff x="0" y="0"/>
-          <a:chExt cx="0" cy="0"/>
-        </a:xfrm>
-      </p:grpSpPr>
+      <p:grpSpPr/>
       <p:sp>
         <p:nvSpPr>
           <p:cNvPr id="2" name="TextBox 1"/>
@@ -3217,7 +3215,6 @@
           <a:lstStyle/>
           <a:p>
             <a:pPr algn="ctr"/>
-            <a:endParaRPr/>
           </a:p>
         </p:txBody>
       </p:sp>
@@ -3263,7 +3260,6 @@
           <a:lstStyle/>
           <a:p>
             <a:pPr algn="ctr"/>
-            <a:endParaRPr/>
           </a:p>
         </p:txBody>
       </p:sp>
@@ -3297,7 +3293,7 @@
                 </a:solidFill>
                 <a:latin typeface="Segoe UI"/>
               </a:rPr>
-              <a:t>TEAM</a:t>
+              <a:t>KKR - Kolkata Kode Riders</a:t>
             </a:r>
           </a:p>
         </p:txBody>
@@ -3419,7 +3415,7 @@
 </file>
 
 <file path=ppt/slides/slide2.xml><?xml version="1.0" encoding="utf-8"?>
-<p:sld xmlns:a="http://schemas.openxmlformats.org/drawingml/2006/main" xmlns:r="http://schemas.openxmlformats.org/officeDocument/2006/relationships" xmlns:p="http://schemas.openxmlformats.org/presentationml/2006/main">
+<p:sld xmlns:a="http://schemas.openxmlformats.org/drawingml/2006/main" xmlns:p="http://schemas.openxmlformats.org/presentationml/2006/main" xmlns:r="http://schemas.openxmlformats.org/officeDocument/2006/relationships">
   <p:cSld>
     <p:bg>
       <p:bgPr>
@@ -3435,14 +3431,7 @@
         <p:cNvGrpSpPr/>
         <p:nvPr/>
       </p:nvGrpSpPr>
-      <p:grpSpPr>
-        <a:xfrm>
-          <a:off x="0" y="0"/>
-          <a:ext cx="0" cy="0"/>
-          <a:chOff x="0" y="0"/>
-          <a:chExt cx="0" cy="0"/>
-        </a:xfrm>
-      </p:grpSpPr>
+      <p:grpSpPr/>
       <p:sp>
         <p:nvSpPr>
           <p:cNvPr id="2" name="TextBox 1"/>
@@ -3800,7 +3789,6 @@
           <a:lstStyle/>
           <a:p>
             <a:pPr algn="ctr"/>
-            <a:endParaRPr/>
           </a:p>
         </p:txBody>
       </p:sp>
@@ -3850,7 +3838,7 @@
         </p:nvSpPr>
         <p:spPr>
           <a:xfrm>
-            <a:off x="6094476" y="4114800"/>
+            <a:off x="6858000" y="4114800"/>
             <a:ext cx="4114800" cy="1371600"/>
           </a:xfrm>
           <a:prstGeom prst="rect">
@@ -3866,7 +3854,7 @@
           <a:p>
             <a:pPr algn="l"/>
             <a:r>
-              <a:rPr sz="2400" b="1" dirty="0">
+              <a:rPr sz="2400" b="1">
                 <a:solidFill>
                   <a:srgbClr val="FF6600"/>
                 </a:solidFill>
@@ -3887,7 +3875,7 @@
 </file>
 
 <file path=ppt/slides/slide3.xml><?xml version="1.0" encoding="utf-8"?>
-<p:sld xmlns:a="http://schemas.openxmlformats.org/drawingml/2006/main" xmlns:r="http://schemas.openxmlformats.org/officeDocument/2006/relationships" xmlns:p="http://schemas.openxmlformats.org/presentationml/2006/main">
+<p:sld xmlns:a="http://schemas.openxmlformats.org/drawingml/2006/main" xmlns:p="http://schemas.openxmlformats.org/presentationml/2006/main" xmlns:r="http://schemas.openxmlformats.org/officeDocument/2006/relationships">
   <p:cSld>
     <p:bg>
       <p:bgPr>
@@ -3903,14 +3891,7 @@
         <p:cNvGrpSpPr/>
         <p:nvPr/>
       </p:nvGrpSpPr>
-      <p:grpSpPr>
-        <a:xfrm>
-          <a:off x="0" y="0"/>
-          <a:ext cx="0" cy="0"/>
-          <a:chOff x="0" y="0"/>
-          <a:chExt cx="0" cy="0"/>
-        </a:xfrm>
-      </p:grpSpPr>
+      <p:grpSpPr/>
       <p:sp>
         <p:nvSpPr>
           <p:cNvPr id="2" name="TextBox 1"/>
@@ -3988,7 +3969,6 @@
           <a:lstStyle/>
           <a:p>
             <a:pPr algn="ctr"/>
-            <a:endParaRPr/>
           </a:p>
         </p:txBody>
       </p:sp>
@@ -4104,7 +4084,6 @@
           <a:lstStyle/>
           <a:p>
             <a:pPr algn="ctr"/>
-            <a:endParaRPr/>
           </a:p>
         </p:txBody>
       </p:sp>
@@ -4220,7 +4199,6 @@
           <a:lstStyle/>
           <a:p>
             <a:pPr algn="ctr"/>
-            <a:endParaRPr/>
           </a:p>
         </p:txBody>
       </p:sp>
@@ -4336,7 +4314,6 @@
           <a:lstStyle/>
           <a:p>
             <a:pPr algn="ctr"/>
-            <a:endParaRPr/>
           </a:p>
         </p:txBody>
       </p:sp>
@@ -4452,7 +4429,6 @@
           <a:lstStyle/>
           <a:p>
             <a:pPr algn="ctr"/>
-            <a:endParaRPr/>
           </a:p>
         </p:txBody>
       </p:sp>
@@ -4568,7 +4544,6 @@
           <a:lstStyle/>
           <a:p>
             <a:pPr algn="ctr"/>
-            <a:endParaRPr/>
           </a:p>
         </p:txBody>
       </p:sp>
@@ -4651,7 +4626,7 @@
 </file>
 
 <file path=ppt/slides/slide4.xml><?xml version="1.0" encoding="utf-8"?>
-<p:sld xmlns:a="http://schemas.openxmlformats.org/drawingml/2006/main" xmlns:r="http://schemas.openxmlformats.org/officeDocument/2006/relationships" xmlns:p="http://schemas.openxmlformats.org/presentationml/2006/main">
+<p:sld xmlns:a="http://schemas.openxmlformats.org/drawingml/2006/main" xmlns:p="http://schemas.openxmlformats.org/presentationml/2006/main" xmlns:r="http://schemas.openxmlformats.org/officeDocument/2006/relationships">
   <p:cSld>
     <p:bg>
       <p:bgPr>
@@ -4667,14 +4642,7 @@
         <p:cNvGrpSpPr/>
         <p:nvPr/>
       </p:nvGrpSpPr>
-      <p:grpSpPr>
-        <a:xfrm>
-          <a:off x="0" y="0"/>
-          <a:ext cx="0" cy="0"/>
-          <a:chOff x="0" y="0"/>
-          <a:chExt cx="0" cy="0"/>
-        </a:xfrm>
-      </p:grpSpPr>
+      <p:grpSpPr/>
       <p:sp>
         <p:nvSpPr>
           <p:cNvPr id="2" name="TextBox 1"/>
@@ -4752,7 +4720,6 @@
           <a:lstStyle/>
           <a:p>
             <a:pPr algn="ctr"/>
-            <a:endParaRPr/>
           </a:p>
         </p:txBody>
       </p:sp>
@@ -4868,7 +4835,6 @@
           <a:lstStyle/>
           <a:p>
             <a:pPr algn="ctr"/>
-            <a:endParaRPr/>
           </a:p>
         </p:txBody>
       </p:sp>
@@ -4984,7 +4950,6 @@
           <a:lstStyle/>
           <a:p>
             <a:pPr algn="ctr"/>
-            <a:endParaRPr/>
           </a:p>
         </p:txBody>
       </p:sp>
@@ -5066,8 +5031,8 @@
         </p:nvSpPr>
         <p:spPr>
           <a:xfrm>
-            <a:off x="4032504" y="2628901"/>
-            <a:ext cx="4114800" cy="1463039"/>
+            <a:off x="4032504" y="2606040"/>
+            <a:ext cx="4114800" cy="1600200"/>
           </a:xfrm>
           <a:prstGeom prst="roundRect">
             <a:avLst/>
@@ -5100,7 +5065,6 @@
           <a:lstStyle/>
           <a:p>
             <a:pPr algn="ctr"/>
-            <a:endParaRPr/>
           </a:p>
         </p:txBody>
       </p:sp>
@@ -5112,8 +5076,8 @@
         </p:nvSpPr>
         <p:spPr>
           <a:xfrm>
-            <a:off x="4032504" y="2583179"/>
-            <a:ext cx="4037131" cy="1492716"/>
+            <a:off x="4123944" y="2651760"/>
+            <a:ext cx="3931920" cy="1371600"/>
           </a:xfrm>
           <a:prstGeom prst="rect">
             <a:avLst/>
@@ -5127,60 +5091,15 @@
           <a:lstStyle/>
           <a:p>
             <a:pPr algn="ctr"/>
-            <a:endParaRPr lang="en-US" sz="1300" b="1" dirty="0">
-              <a:solidFill>
-                <a:srgbClr val="F0F0F0"/>
-              </a:solidFill>
-              <a:latin typeface="Arial"/>
-            </a:endParaRPr>
-          </a:p>
-          <a:p>
-            <a:pPr algn="ctr"/>
-            <a:r>
-              <a:rPr sz="1300" b="1" dirty="0">
+            <a:r>
+              <a:rPr sz="1300" b="1">
                 <a:solidFill>
                   <a:srgbClr val="F0F0F0"/>
                 </a:solidFill>
                 <a:latin typeface="Arial"/>
               </a:rPr>
               <a:t>INTERRUPTION-AWARE COORDINATION LAYER
-</a:t>
-            </a:r>
-            <a:endParaRPr lang="en-US" sz="1300" b="1" dirty="0">
-              <a:solidFill>
-                <a:srgbClr val="F0F0F0"/>
-              </a:solidFill>
-              <a:latin typeface="Arial"/>
-            </a:endParaRPr>
-          </a:p>
-          <a:p>
-            <a:pPr algn="ctr"/>
-            <a:endParaRPr lang="en-IN" sz="1300" b="1" dirty="0">
-              <a:solidFill>
-                <a:srgbClr val="F0F0F0"/>
-              </a:solidFill>
-              <a:latin typeface="Arial"/>
-            </a:endParaRPr>
-          </a:p>
-          <a:p>
-            <a:pPr algn="ctr"/>
-            <a:r>
-              <a:rPr sz="1300" b="1" dirty="0" err="1">
-                <a:solidFill>
-                  <a:srgbClr val="F0F0F0"/>
-                </a:solidFill>
-                <a:latin typeface="Arial"/>
-              </a:rPr>
-              <a:t>generation_id</a:t>
-            </a:r>
-            <a:r>
-              <a:rPr sz="1300" b="1" dirty="0">
-                <a:solidFill>
-                  <a:srgbClr val="F0F0F0"/>
-                </a:solidFill>
-                <a:latin typeface="Arial"/>
-              </a:rPr>
-              <a:t>
+generation_id
 cancellation
 state validation</a:t>
             </a:r>
@@ -5264,7 +5183,6 @@
           <a:lstStyle/>
           <a:p>
             <a:pPr algn="ctr"/>
-            <a:endParaRPr/>
           </a:p>
         </p:txBody>
       </p:sp>
@@ -5380,7 +5298,6 @@
           <a:lstStyle/>
           <a:p>
             <a:pPr algn="ctr"/>
-            <a:endParaRPr/>
           </a:p>
         </p:txBody>
       </p:sp>
@@ -5496,7 +5413,6 @@
           <a:lstStyle/>
           <a:p>
             <a:pPr algn="ctr"/>
-            <a:endParaRPr/>
           </a:p>
         </p:txBody>
       </p:sp>
@@ -5612,7 +5528,6 @@
           <a:lstStyle/>
           <a:p>
             <a:pPr algn="ctr"/>
-            <a:endParaRPr/>
           </a:p>
         </p:txBody>
       </p:sp>
@@ -5660,7 +5575,7 @@
         <p:spPr>
           <a:xfrm>
             <a:off x="1371600" y="2697480"/>
-            <a:ext cx="2377440" cy="1203960"/>
+            <a:ext cx="2377440" cy="1097280"/>
           </a:xfrm>
           <a:prstGeom prst="roundRect">
             <a:avLst/>
@@ -5693,7 +5608,6 @@
           <a:lstStyle/>
           <a:p>
             <a:pPr algn="ctr"/>
-            <a:endParaRPr/>
           </a:p>
         </p:txBody>
       </p:sp>
@@ -5705,7 +5619,7 @@
         </p:nvSpPr>
         <p:spPr>
           <a:xfrm>
-            <a:off x="1490472" y="2702560"/>
+            <a:off x="1463040" y="2788920"/>
             <a:ext cx="2194560" cy="914400"/>
           </a:xfrm>
           <a:prstGeom prst="rect">
@@ -5721,7 +5635,7 @@
           <a:p>
             <a:pPr algn="ctr"/>
             <a:r>
-              <a:rPr sz="1300" b="1" dirty="0">
+              <a:rPr sz="1300" b="1">
                 <a:solidFill>
                   <a:srgbClr val="FF6600"/>
                 </a:solidFill>
@@ -5778,7 +5692,6 @@
           <a:lstStyle/>
           <a:p>
             <a:pPr algn="ctr"/>
-            <a:endParaRPr/>
           </a:p>
         </p:txBody>
       </p:sp>
@@ -5828,7 +5741,7 @@
 </file>
 
 <file path=ppt/slides/slide5.xml><?xml version="1.0" encoding="utf-8"?>
-<p:sld xmlns:a="http://schemas.openxmlformats.org/drawingml/2006/main" xmlns:r="http://schemas.openxmlformats.org/officeDocument/2006/relationships" xmlns:p="http://schemas.openxmlformats.org/presentationml/2006/main">
+<p:sld xmlns:a="http://schemas.openxmlformats.org/drawingml/2006/main" xmlns:p="http://schemas.openxmlformats.org/presentationml/2006/main" xmlns:r="http://schemas.openxmlformats.org/officeDocument/2006/relationships">
   <p:cSld>
     <p:bg>
       <p:bgPr>
@@ -5844,14 +5757,7 @@
         <p:cNvGrpSpPr/>
         <p:nvPr/>
       </p:nvGrpSpPr>
-      <p:grpSpPr>
-        <a:xfrm>
-          <a:off x="0" y="0"/>
-          <a:ext cx="0" cy="0"/>
-          <a:chOff x="0" y="0"/>
-          <a:chExt cx="0" cy="0"/>
-        </a:xfrm>
-      </p:grpSpPr>
+      <p:grpSpPr/>
       <p:sp>
         <p:nvSpPr>
           <p:cNvPr id="2" name="TextBox 1"/>
@@ -5964,7 +5870,6 @@
           <a:lstStyle/>
           <a:p>
             <a:pPr algn="ctr"/>
-            <a:endParaRPr/>
           </a:p>
         </p:txBody>
       </p:sp>
@@ -6080,7 +5985,6 @@
           <a:lstStyle/>
           <a:p>
             <a:pPr algn="ctr"/>
-            <a:endParaRPr/>
           </a:p>
         </p:txBody>
       </p:sp>
@@ -6196,7 +6100,6 @@
           <a:lstStyle/>
           <a:p>
             <a:pPr algn="ctr"/>
-            <a:endParaRPr/>
           </a:p>
         </p:txBody>
       </p:sp>
@@ -6312,7 +6215,6 @@
           <a:lstStyle/>
           <a:p>
             <a:pPr algn="ctr"/>
-            <a:endParaRPr/>
           </a:p>
         </p:txBody>
       </p:sp>
@@ -6396,7 +6298,7 @@
 </file>
 
 <file path=ppt/slides/slide6.xml><?xml version="1.0" encoding="utf-8"?>
-<p:sld xmlns:a="http://schemas.openxmlformats.org/drawingml/2006/main" xmlns:r="http://schemas.openxmlformats.org/officeDocument/2006/relationships" xmlns:p="http://schemas.openxmlformats.org/presentationml/2006/main">
+<p:sld xmlns:a="http://schemas.openxmlformats.org/drawingml/2006/main" xmlns:p="http://schemas.openxmlformats.org/presentationml/2006/main" xmlns:r="http://schemas.openxmlformats.org/officeDocument/2006/relationships">
   <p:cSld>
     <p:bg>
       <p:bgPr>
@@ -6412,14 +6314,7 @@
         <p:cNvGrpSpPr/>
         <p:nvPr/>
       </p:nvGrpSpPr>
-      <p:grpSpPr>
-        <a:xfrm>
-          <a:off x="0" y="0"/>
-          <a:ext cx="0" cy="0"/>
-          <a:chOff x="0" y="0"/>
-          <a:chExt cx="0" cy="0"/>
-        </a:xfrm>
-      </p:grpSpPr>
+      <p:grpSpPr/>
       <p:sp>
         <p:nvSpPr>
           <p:cNvPr id="2" name="TextBox 1"/>
@@ -6748,7 +6643,6 @@
           <a:lstStyle/>
           <a:p>
             <a:pPr algn="ctr"/>
-            <a:endParaRPr/>
           </a:p>
         </p:txBody>
       </p:sp>
@@ -6830,7 +6724,6 @@
           <a:lstStyle/>
           <a:p>
             <a:pPr algn="ctr"/>
-            <a:endParaRPr/>
           </a:p>
         </p:txBody>
       </p:sp>
@@ -6915,7 +6808,7 @@
 </file>
 
 <file path=ppt/slides/slide7.xml><?xml version="1.0" encoding="utf-8"?>
-<p:sld xmlns:a="http://schemas.openxmlformats.org/drawingml/2006/main" xmlns:r="http://schemas.openxmlformats.org/officeDocument/2006/relationships" xmlns:p="http://schemas.openxmlformats.org/presentationml/2006/main">
+<p:sld xmlns:a="http://schemas.openxmlformats.org/drawingml/2006/main" xmlns:p="http://schemas.openxmlformats.org/presentationml/2006/main" xmlns:r="http://schemas.openxmlformats.org/officeDocument/2006/relationships">
   <p:cSld>
     <p:bg>
       <p:bgPr>
@@ -6931,14 +6824,7 @@
         <p:cNvGrpSpPr/>
         <p:nvPr/>
       </p:nvGrpSpPr>
-      <p:grpSpPr>
-        <a:xfrm>
-          <a:off x="0" y="0"/>
-          <a:ext cx="0" cy="0"/>
-          <a:chOff x="0" y="0"/>
-          <a:chExt cx="0" cy="0"/>
-        </a:xfrm>
-      </p:grpSpPr>
+      <p:grpSpPr/>
       <p:sp>
         <p:nvSpPr>
           <p:cNvPr id="2" name="TextBox 1"/>
@@ -7016,7 +6902,6 @@
           <a:lstStyle/>
           <a:p>
             <a:pPr algn="ctr"/>
-            <a:endParaRPr/>
           </a:p>
         </p:txBody>
       </p:sp>
@@ -7202,7 +7087,6 @@
           <a:lstStyle/>
           <a:p>
             <a:pPr algn="ctr"/>
-            <a:endParaRPr/>
           </a:p>
         </p:txBody>
       </p:sp>
@@ -7388,7 +7272,6 @@
           <a:lstStyle/>
           <a:p>
             <a:pPr algn="ctr"/>
-            <a:endParaRPr/>
           </a:p>
         </p:txBody>
       </p:sp>
@@ -7609,7 +7492,6 @@
           <a:lstStyle/>
           <a:p>
             <a:pPr algn="ctr"/>
-            <a:endParaRPr/>
           </a:p>
         </p:txBody>
       </p:sp>
@@ -7657,7 +7539,7 @@
 </file>
 
 <file path=ppt/slides/slide8.xml><?xml version="1.0" encoding="utf-8"?>
-<p:sld xmlns:a="http://schemas.openxmlformats.org/drawingml/2006/main" xmlns:r="http://schemas.openxmlformats.org/officeDocument/2006/relationships" xmlns:p="http://schemas.openxmlformats.org/presentationml/2006/main">
+<p:sld xmlns:a="http://schemas.openxmlformats.org/drawingml/2006/main" xmlns:p="http://schemas.openxmlformats.org/presentationml/2006/main" xmlns:r="http://schemas.openxmlformats.org/officeDocument/2006/relationships">
   <p:cSld>
     <p:bg>
       <p:bgPr>
@@ -7673,14 +7555,7 @@
         <p:cNvGrpSpPr/>
         <p:nvPr/>
       </p:nvGrpSpPr>
-      <p:grpSpPr>
-        <a:xfrm>
-          <a:off x="0" y="0"/>
-          <a:ext cx="0" cy="0"/>
-          <a:chOff x="0" y="0"/>
-          <a:chExt cx="0" cy="0"/>
-        </a:xfrm>
-      </p:grpSpPr>
+      <p:grpSpPr/>
       <p:sp>
         <p:nvSpPr>
           <p:cNvPr id="2" name="TextBox 1"/>
@@ -7825,7 +7700,7 @@
                 </a:solidFill>
                 <a:latin typeface="Segoe UI"/>
               </a:rPr>
-              <a:t>Team: Arhit Basu (Leader) • Tiyas Das • Subarta Ghosh • Soumen Mondal</a:t>
+              <a:t>KKR - Kolkata Kode Riders: Arhit Basu (Leader) • Tiyas Das • Subarta Ghosh • Soumen Mondal</a:t>
             </a:r>
           </a:p>
         </p:txBody>

</xml_diff>